<commit_message>
Update Pacevera product vision docs
</commit_message>
<xml_diff>
--- a/docs/Fitness-MCP-Product-Vision.pptx
+++ b/docs/Fitness-MCP-Product-Vision.pptx
@@ -3244,6 +3244,10 @@
           </a:solidFill>
           <a:ln/>
         </p:spPr>
+        <p:txBody>
+          <a:bodyPr/>
+          <a:p/>
+        </p:txBody>
       </p:sp>
       <p:sp>
         <p:nvSpPr>
@@ -3266,6 +3270,10 @@
           </a:solidFill>
           <a:ln/>
         </p:spPr>
+        <p:txBody>
+          <a:bodyPr/>
+          <a:p/>
+        </p:txBody>
       </p:sp>
       <p:sp>
         <p:nvSpPr>
@@ -3286,6 +3294,10 @@
           </a:solidFill>
           <a:ln/>
         </p:spPr>
+        <p:txBody>
+          <a:bodyPr/>
+          <a:p/>
+        </p:txBody>
       </p:sp>
       <p:sp>
         <p:nvSpPr>
@@ -3362,7 +3374,7 @@
                 <a:ea typeface="Arial" pitchFamily="34" charset="-122"/>
                 <a:cs typeface="Arial" pitchFamily="34" charset="-120"/>
               </a:rPr>
-              <a:t>Evidra</a:t>
+              <a:t>Pacevera</a:t>
             </a:r>
             <a:endParaRPr lang="en-US" sz="5000" dirty="0"/>
           </a:p>
@@ -3452,6 +3464,10 @@
             <a:prstDash val="solid"/>
           </a:ln>
         </p:spPr>
+        <p:txBody>
+          <a:bodyPr/>
+          <a:p/>
+        </p:txBody>
       </p:sp>
       <p:sp>
         <p:nvSpPr>
@@ -3544,6 +3560,10 @@
           </a:solidFill>
           <a:ln/>
         </p:spPr>
+        <p:txBody>
+          <a:bodyPr/>
+          <a:p/>
+        </p:txBody>
       </p:sp>
       <p:sp>
         <p:nvSpPr>
@@ -3686,6 +3706,10 @@
           </a:solidFill>
           <a:ln/>
         </p:spPr>
+        <p:txBody>
+          <a:bodyPr/>
+          <a:p/>
+        </p:txBody>
       </p:sp>
       <p:sp>
         <p:nvSpPr>
@@ -3786,6 +3810,10 @@
           </a:solidFill>
           <a:ln/>
         </p:spPr>
+        <p:txBody>
+          <a:bodyPr/>
+          <a:p/>
+        </p:txBody>
       </p:sp>
       <p:sp>
         <p:nvSpPr>
@@ -3956,6 +3984,10 @@
           </a:solidFill>
           <a:ln/>
         </p:spPr>
+        <p:txBody>
+          <a:bodyPr/>
+          <a:p/>
+        </p:txBody>
       </p:sp>
       <p:sp>
         <p:nvSpPr>
@@ -4098,6 +4130,10 @@
           </a:solidFill>
           <a:ln/>
         </p:spPr>
+        <p:txBody>
+          <a:bodyPr/>
+          <a:p/>
+        </p:txBody>
       </p:sp>
       <p:sp>
         <p:nvSpPr>
@@ -4198,6 +4234,10 @@
           </a:solidFill>
           <a:ln/>
         </p:spPr>
+        <p:txBody>
+          <a:bodyPr/>
+          <a:p/>
+        </p:txBody>
       </p:sp>
       <p:sp>
         <p:nvSpPr>
@@ -4298,6 +4338,10 @@
           </a:solidFill>
           <a:ln/>
         </p:spPr>
+        <p:txBody>
+          <a:bodyPr/>
+          <a:p/>
+        </p:txBody>
       </p:sp>
       <p:sp>
         <p:nvSpPr>
@@ -4398,6 +4442,10 @@
           </a:solidFill>
           <a:ln/>
         </p:spPr>
+        <p:txBody>
+          <a:bodyPr/>
+          <a:p/>
+        </p:txBody>
       </p:sp>
       <p:sp>
         <p:nvSpPr>
@@ -4498,6 +4546,10 @@
           </a:solidFill>
           <a:ln/>
         </p:spPr>
+        <p:txBody>
+          <a:bodyPr/>
+          <a:p/>
+        </p:txBody>
       </p:sp>
       <p:sp>
         <p:nvSpPr>
@@ -4598,6 +4650,10 @@
           </a:solidFill>
           <a:ln/>
         </p:spPr>
+        <p:txBody>
+          <a:bodyPr/>
+          <a:p/>
+        </p:txBody>
       </p:sp>
       <p:sp>
         <p:nvSpPr>
@@ -4659,6 +4715,10 @@
           </a:solidFill>
           <a:ln/>
         </p:spPr>
+        <p:txBody>
+          <a:bodyPr/>
+          <a:p/>
+        </p:txBody>
       </p:sp>
       <p:sp>
         <p:nvSpPr>
@@ -4759,6 +4819,10 @@
           </a:solidFill>
           <a:ln/>
         </p:spPr>
+        <p:txBody>
+          <a:bodyPr/>
+          <a:p/>
+        </p:txBody>
       </p:sp>
       <p:sp>
         <p:nvSpPr>
@@ -4929,6 +4993,10 @@
           </a:solidFill>
           <a:ln/>
         </p:spPr>
+        <p:txBody>
+          <a:bodyPr/>
+          <a:p/>
+        </p:txBody>
       </p:sp>
       <p:sp>
         <p:nvSpPr>
@@ -5071,6 +5139,10 @@
           </a:solidFill>
           <a:ln/>
         </p:spPr>
+        <p:txBody>
+          <a:bodyPr/>
+          <a:p/>
+        </p:txBody>
       </p:sp>
       <p:sp>
         <p:nvSpPr>
@@ -5195,6 +5267,10 @@
           </a:solidFill>
           <a:ln/>
         </p:spPr>
+        <p:txBody>
+          <a:bodyPr/>
+          <a:p/>
+        </p:txBody>
       </p:sp>
       <p:sp>
         <p:nvSpPr>
@@ -5215,6 +5291,10 @@
           </a:solidFill>
           <a:ln/>
         </p:spPr>
+        <p:txBody>
+          <a:bodyPr/>
+          <a:p/>
+        </p:txBody>
       </p:sp>
       <p:sp>
         <p:nvSpPr>
@@ -5315,6 +5395,10 @@
           </a:solidFill>
           <a:ln/>
         </p:spPr>
+        <p:txBody>
+          <a:bodyPr/>
+          <a:p/>
+        </p:txBody>
       </p:sp>
       <p:sp>
         <p:nvSpPr>
@@ -5335,6 +5419,10 @@
           </a:solidFill>
           <a:ln/>
         </p:spPr>
+        <p:txBody>
+          <a:bodyPr/>
+          <a:p/>
+        </p:txBody>
       </p:sp>
       <p:sp>
         <p:nvSpPr>
@@ -5435,6 +5523,10 @@
           </a:solidFill>
           <a:ln/>
         </p:spPr>
+        <p:txBody>
+          <a:bodyPr/>
+          <a:p/>
+        </p:txBody>
       </p:sp>
       <p:sp>
         <p:nvSpPr>
@@ -5455,6 +5547,10 @@
           </a:solidFill>
           <a:ln/>
         </p:spPr>
+        <p:txBody>
+          <a:bodyPr/>
+          <a:p/>
+        </p:txBody>
       </p:sp>
       <p:sp>
         <p:nvSpPr>
@@ -5664,6 +5760,10 @@
           </a:solidFill>
           <a:ln/>
         </p:spPr>
+        <p:txBody>
+          <a:bodyPr/>
+          <a:p/>
+        </p:txBody>
       </p:sp>
       <p:sp>
         <p:nvSpPr>
@@ -5806,6 +5906,10 @@
           </a:solidFill>
           <a:ln/>
         </p:spPr>
+        <p:txBody>
+          <a:bodyPr/>
+          <a:p/>
+        </p:txBody>
       </p:sp>
       <p:sp>
         <p:nvSpPr>
@@ -5867,6 +5971,10 @@
           </a:solidFill>
           <a:ln/>
         </p:spPr>
+        <p:txBody>
+          <a:bodyPr/>
+          <a:p/>
+        </p:txBody>
       </p:sp>
       <p:sp>
         <p:nvSpPr>
@@ -5928,6 +6036,10 @@
           </a:solidFill>
           <a:ln/>
         </p:spPr>
+        <p:txBody>
+          <a:bodyPr/>
+          <a:p/>
+        </p:txBody>
       </p:sp>
       <p:sp>
         <p:nvSpPr>
@@ -5989,6 +6101,10 @@
           </a:solidFill>
           <a:ln/>
         </p:spPr>
+        <p:txBody>
+          <a:bodyPr/>
+          <a:p/>
+        </p:txBody>
       </p:sp>
       <p:sp>
         <p:nvSpPr>
@@ -6050,6 +6166,10 @@
           </a:solidFill>
           <a:ln/>
         </p:spPr>
+        <p:txBody>
+          <a:bodyPr/>
+          <a:p/>
+        </p:txBody>
       </p:sp>
       <p:sp>
         <p:nvSpPr>
@@ -6150,6 +6270,10 @@
           </a:solidFill>
           <a:ln/>
         </p:spPr>
+        <p:txBody>
+          <a:bodyPr/>
+          <a:p/>
+        </p:txBody>
       </p:sp>
       <p:sp>
         <p:nvSpPr>
@@ -6273,6 +6397,10 @@
           </a:solidFill>
           <a:ln/>
         </p:spPr>
+        <p:txBody>
+          <a:bodyPr/>
+          <a:p/>
+        </p:txBody>
       </p:sp>
       <p:sp>
         <p:nvSpPr>
@@ -6506,6 +6634,10 @@
           </a:solidFill>
           <a:ln/>
         </p:spPr>
+        <p:txBody>
+          <a:bodyPr/>
+          <a:p/>
+        </p:txBody>
       </p:sp>
       <p:sp>
         <p:nvSpPr>
@@ -6648,6 +6780,10 @@
           </a:solidFill>
           <a:ln/>
         </p:spPr>
+        <p:txBody>
+          <a:bodyPr/>
+          <a:p/>
+        </p:txBody>
       </p:sp>
       <p:sp>
         <p:nvSpPr>
@@ -6668,6 +6804,10 @@
           </a:solidFill>
           <a:ln/>
         </p:spPr>
+        <p:txBody>
+          <a:bodyPr/>
+          <a:p/>
+        </p:txBody>
       </p:sp>
       <p:sp>
         <p:nvSpPr>
@@ -6871,6 +7011,10 @@
           </a:solidFill>
           <a:ln/>
         </p:spPr>
+        <p:txBody>
+          <a:bodyPr/>
+          <a:p/>
+        </p:txBody>
       </p:sp>
       <p:sp>
         <p:nvSpPr>
@@ -6891,6 +7035,10 @@
           </a:solidFill>
           <a:ln/>
         </p:spPr>
+        <p:txBody>
+          <a:bodyPr/>
+          <a:p/>
+        </p:txBody>
       </p:sp>
       <p:sp>
         <p:nvSpPr>
@@ -7094,6 +7242,10 @@
           </a:solidFill>
           <a:ln/>
         </p:spPr>
+        <p:txBody>
+          <a:bodyPr/>
+          <a:p/>
+        </p:txBody>
       </p:sp>
       <p:sp>
         <p:nvSpPr>
@@ -7114,6 +7266,10 @@
           </a:solidFill>
           <a:ln/>
         </p:spPr>
+        <p:txBody>
+          <a:bodyPr/>
+          <a:p/>
+        </p:txBody>
       </p:sp>
       <p:sp>
         <p:nvSpPr>
@@ -7297,6 +7453,10 @@
           </a:solidFill>
           <a:ln/>
         </p:spPr>
+        <p:txBody>
+          <a:bodyPr/>
+          <a:p/>
+        </p:txBody>
       </p:sp>
       <p:sp>
         <p:nvSpPr>
@@ -7317,6 +7477,10 @@
           </a:solidFill>
           <a:ln/>
         </p:spPr>
+        <p:txBody>
+          <a:bodyPr/>
+          <a:p/>
+        </p:txBody>
       </p:sp>
       <p:sp>
         <p:nvSpPr>
@@ -7550,6 +7714,10 @@
           </a:solidFill>
           <a:ln/>
         </p:spPr>
+        <p:txBody>
+          <a:bodyPr/>
+          <a:p/>
+        </p:txBody>
       </p:sp>
       <p:sp>
         <p:nvSpPr>
@@ -7692,6 +7860,10 @@
           </a:solidFill>
           <a:ln/>
         </p:spPr>
+        <p:txBody>
+          <a:bodyPr/>
+          <a:p/>
+        </p:txBody>
       </p:sp>
       <p:sp>
         <p:nvSpPr>
@@ -7792,6 +7964,10 @@
           </a:solidFill>
           <a:ln/>
         </p:spPr>
+        <p:txBody>
+          <a:bodyPr/>
+          <a:p/>
+        </p:txBody>
       </p:sp>
       <p:sp>
         <p:nvSpPr>
@@ -7853,6 +8029,10 @@
           </a:solidFill>
           <a:ln/>
         </p:spPr>
+        <p:txBody>
+          <a:bodyPr/>
+          <a:p/>
+        </p:txBody>
       </p:sp>
       <p:sp>
         <p:nvSpPr>
@@ -7953,6 +8133,10 @@
           </a:solidFill>
           <a:ln/>
         </p:spPr>
+        <p:txBody>
+          <a:bodyPr/>
+          <a:p/>
+        </p:txBody>
       </p:sp>
       <p:sp>
         <p:nvSpPr>
@@ -8014,6 +8198,10 @@
           </a:solidFill>
           <a:ln/>
         </p:spPr>
+        <p:txBody>
+          <a:bodyPr/>
+          <a:p/>
+        </p:txBody>
       </p:sp>
       <p:sp>
         <p:nvSpPr>
@@ -8114,6 +8302,10 @@
           </a:solidFill>
           <a:ln/>
         </p:spPr>
+        <p:txBody>
+          <a:bodyPr/>
+          <a:p/>
+        </p:txBody>
       </p:sp>
       <p:sp>
         <p:nvSpPr>
@@ -8284,6 +8476,10 @@
           </a:solidFill>
           <a:ln/>
         </p:spPr>
+        <p:txBody>
+          <a:bodyPr/>
+          <a:p/>
+        </p:txBody>
       </p:sp>
       <p:sp>
         <p:nvSpPr>
@@ -8426,6 +8622,10 @@
           </a:solidFill>
           <a:ln/>
         </p:spPr>
+        <p:txBody>
+          <a:bodyPr/>
+          <a:p/>
+        </p:txBody>
       </p:sp>
       <p:sp>
         <p:nvSpPr>
@@ -8776,6 +8976,10 @@
           </a:solidFill>
           <a:ln/>
         </p:spPr>
+        <p:txBody>
+          <a:bodyPr/>
+          <a:p/>
+        </p:txBody>
       </p:sp>
       <p:sp>
         <p:nvSpPr>
@@ -8876,6 +9080,10 @@
           </a:solidFill>
           <a:ln/>
         </p:spPr>
+        <p:txBody>
+          <a:bodyPr/>
+          <a:p/>
+        </p:txBody>
       </p:sp>
       <p:sp>
         <p:nvSpPr>
@@ -8898,6 +9106,10 @@
           </a:solidFill>
           <a:ln/>
         </p:spPr>
+        <p:txBody>
+          <a:bodyPr/>
+          <a:p/>
+        </p:txBody>
       </p:sp>
       <p:sp>
         <p:nvSpPr>
@@ -8998,6 +9210,10 @@
           </a:solidFill>
           <a:ln/>
         </p:spPr>
+        <p:txBody>
+          <a:bodyPr/>
+          <a:p/>
+        </p:txBody>
       </p:sp>
       <p:sp>
         <p:nvSpPr>
@@ -9020,6 +9236,10 @@
           </a:solidFill>
           <a:ln/>
         </p:spPr>
+        <p:txBody>
+          <a:bodyPr/>
+          <a:p/>
+        </p:txBody>
       </p:sp>
       <p:sp>
         <p:nvSpPr>
@@ -9120,6 +9340,10 @@
           </a:solidFill>
           <a:ln/>
         </p:spPr>
+        <p:txBody>
+          <a:bodyPr/>
+          <a:p/>
+        </p:txBody>
       </p:sp>
       <p:sp>
         <p:nvSpPr>
@@ -9142,6 +9366,10 @@
           </a:solidFill>
           <a:ln/>
         </p:spPr>
+        <p:txBody>
+          <a:bodyPr/>
+          <a:p/>
+        </p:txBody>
       </p:sp>
       <p:sp>
         <p:nvSpPr>
@@ -9273,6 +9501,10 @@
           </a:solidFill>
           <a:ln/>
         </p:spPr>
+        <p:txBody>
+          <a:bodyPr/>
+          <a:p/>
+        </p:txBody>
       </p:sp>
       <p:sp>
         <p:nvSpPr>
@@ -9415,6 +9647,10 @@
           </a:solidFill>
           <a:ln/>
         </p:spPr>
+        <p:txBody>
+          <a:bodyPr/>
+          <a:p/>
+        </p:txBody>
       </p:sp>
       <p:sp>
         <p:nvSpPr>
@@ -9617,6 +9853,10 @@
           </a:solidFill>
           <a:ln/>
         </p:spPr>
+        <p:txBody>
+          <a:bodyPr/>
+          <a:p/>
+        </p:txBody>
       </p:sp>
       <p:sp>
         <p:nvSpPr>
@@ -9819,6 +10059,10 @@
           </a:solidFill>
           <a:ln/>
         </p:spPr>
+        <p:txBody>
+          <a:bodyPr/>
+          <a:p/>
+        </p:txBody>
       </p:sp>
       <p:sp>
         <p:nvSpPr>
@@ -10032,6 +10276,10 @@
           </a:solidFill>
           <a:ln/>
         </p:spPr>
+        <p:txBody>
+          <a:bodyPr/>
+          <a:p/>
+        </p:txBody>
       </p:sp>
       <p:sp>
         <p:nvSpPr>
@@ -10174,6 +10422,10 @@
           </a:solidFill>
           <a:ln/>
         </p:spPr>
+        <p:txBody>
+          <a:bodyPr/>
+          <a:p/>
+        </p:txBody>
       </p:sp>
       <p:sp>
         <p:nvSpPr>
@@ -10235,6 +10487,10 @@
           </a:solidFill>
           <a:ln/>
         </p:spPr>
+        <p:txBody>
+          <a:bodyPr/>
+          <a:p/>
+        </p:txBody>
       </p:sp>
       <p:sp>
         <p:nvSpPr>
@@ -10296,6 +10552,10 @@
           </a:solidFill>
           <a:ln/>
         </p:spPr>
+        <p:txBody>
+          <a:bodyPr/>
+          <a:p/>
+        </p:txBody>
       </p:sp>
       <p:sp>
         <p:nvSpPr>
@@ -10357,6 +10617,10 @@
           </a:solidFill>
           <a:ln/>
         </p:spPr>
+        <p:txBody>
+          <a:bodyPr/>
+          <a:p/>
+        </p:txBody>
       </p:sp>
       <p:sp>
         <p:nvSpPr>
@@ -10418,6 +10682,10 @@
           </a:solidFill>
           <a:ln/>
         </p:spPr>
+        <p:txBody>
+          <a:bodyPr/>
+          <a:p/>
+        </p:txBody>
       </p:sp>
       <p:sp>
         <p:nvSpPr>
@@ -10479,6 +10747,10 @@
           </a:solidFill>
           <a:ln/>
         </p:spPr>
+        <p:txBody>
+          <a:bodyPr/>
+          <a:p/>
+        </p:txBody>
       </p:sp>
       <p:sp>
         <p:nvSpPr>
@@ -10540,6 +10812,10 @@
           </a:solidFill>
           <a:ln/>
         </p:spPr>
+        <p:txBody>
+          <a:bodyPr/>
+          <a:p/>
+        </p:txBody>
       </p:sp>
       <p:sp>
         <p:nvSpPr>
@@ -10601,6 +10877,10 @@
           </a:solidFill>
           <a:ln/>
         </p:spPr>
+        <p:txBody>
+          <a:bodyPr/>
+          <a:p/>
+        </p:txBody>
       </p:sp>
       <p:sp>
         <p:nvSpPr>
@@ -10662,6 +10942,10 @@
           </a:solidFill>
           <a:ln/>
         </p:spPr>
+        <p:txBody>
+          <a:bodyPr/>
+          <a:p/>
+        </p:txBody>
       </p:sp>
       <p:sp>
         <p:nvSpPr>
@@ -10723,6 +11007,10 @@
           </a:solidFill>
           <a:ln/>
         </p:spPr>
+        <p:txBody>
+          <a:bodyPr/>
+          <a:p/>
+        </p:txBody>
       </p:sp>
       <p:sp>
         <p:nvSpPr>
@@ -10784,6 +11072,10 @@
           </a:solidFill>
           <a:ln/>
         </p:spPr>
+        <p:txBody>
+          <a:bodyPr/>
+          <a:p/>
+        </p:txBody>
       </p:sp>
       <p:sp>
         <p:nvSpPr>
@@ -10954,6 +11246,10 @@
           </a:solidFill>
           <a:ln/>
         </p:spPr>
+        <p:txBody>
+          <a:bodyPr/>
+          <a:p/>
+        </p:txBody>
       </p:sp>
       <p:sp>
         <p:nvSpPr>
@@ -11096,6 +11392,10 @@
           </a:solidFill>
           <a:ln/>
         </p:spPr>
+        <p:txBody>
+          <a:bodyPr/>
+          <a:p/>
+        </p:txBody>
       </p:sp>
       <p:sp>
         <p:nvSpPr>
@@ -11116,6 +11416,10 @@
           </a:solidFill>
           <a:ln/>
         </p:spPr>
+        <p:txBody>
+          <a:bodyPr/>
+          <a:p/>
+        </p:txBody>
       </p:sp>
       <p:sp>
         <p:nvSpPr>
@@ -11239,6 +11543,10 @@
           </a:solidFill>
           <a:ln/>
         </p:spPr>
+        <p:txBody>
+          <a:bodyPr/>
+          <a:p/>
+        </p:txBody>
       </p:sp>
       <p:sp>
         <p:nvSpPr>
@@ -11259,6 +11567,10 @@
           </a:solidFill>
           <a:ln/>
         </p:spPr>
+        <p:txBody>
+          <a:bodyPr/>
+          <a:p/>
+        </p:txBody>
       </p:sp>
       <p:sp>
         <p:nvSpPr>
@@ -11382,6 +11694,10 @@
           </a:solidFill>
           <a:ln/>
         </p:spPr>
+        <p:txBody>
+          <a:bodyPr/>
+          <a:p/>
+        </p:txBody>
       </p:sp>
       <p:sp>
         <p:nvSpPr>
@@ -11402,6 +11718,10 @@
           </a:solidFill>
           <a:ln/>
         </p:spPr>
+        <p:txBody>
+          <a:bodyPr/>
+          <a:p/>
+        </p:txBody>
       </p:sp>
       <p:sp>
         <p:nvSpPr>
@@ -11525,6 +11845,10 @@
           </a:solidFill>
           <a:ln/>
         </p:spPr>
+        <p:txBody>
+          <a:bodyPr/>
+          <a:p/>
+        </p:txBody>
       </p:sp>
       <p:sp>
         <p:nvSpPr>
@@ -11545,6 +11869,10 @@
           </a:solidFill>
           <a:ln/>
         </p:spPr>
+        <p:txBody>
+          <a:bodyPr/>
+          <a:p/>
+        </p:txBody>
       </p:sp>
       <p:sp>
         <p:nvSpPr>
@@ -11668,6 +11996,10 @@
           </a:solidFill>
           <a:ln/>
         </p:spPr>
+        <p:txBody>
+          <a:bodyPr/>
+          <a:p/>
+        </p:txBody>
       </p:sp>
       <p:sp>
         <p:nvSpPr>
@@ -11688,6 +12020,10 @@
           </a:solidFill>
           <a:ln/>
         </p:spPr>
+        <p:txBody>
+          <a:bodyPr/>
+          <a:p/>
+        </p:txBody>
       </p:sp>
       <p:sp>
         <p:nvSpPr>
@@ -11811,6 +12147,10 @@
           </a:solidFill>
           <a:ln/>
         </p:spPr>
+        <p:txBody>
+          <a:bodyPr/>
+          <a:p/>
+        </p:txBody>
       </p:sp>
       <p:sp>
         <p:nvSpPr>
@@ -11831,6 +12171,10 @@
           </a:solidFill>
           <a:ln/>
         </p:spPr>
+        <p:txBody>
+          <a:bodyPr/>
+          <a:p/>
+        </p:txBody>
       </p:sp>
       <p:sp>
         <p:nvSpPr>
@@ -12024,6 +12368,10 @@
           </a:solidFill>
           <a:ln/>
         </p:spPr>
+        <p:txBody>
+          <a:bodyPr/>
+          <a:p/>
+        </p:txBody>
       </p:sp>
       <p:sp>
         <p:nvSpPr>
@@ -12166,6 +12514,10 @@
           </a:solidFill>
           <a:ln/>
         </p:spPr>
+        <p:txBody>
+          <a:bodyPr/>
+          <a:p/>
+        </p:txBody>
       </p:sp>
       <p:sp>
         <p:nvSpPr>
@@ -12308,6 +12660,10 @@
           </a:solidFill>
           <a:ln/>
         </p:spPr>
+        <p:txBody>
+          <a:bodyPr/>
+          <a:p/>
+        </p:txBody>
       </p:sp>
       <p:sp>
         <p:nvSpPr>
@@ -12450,6 +12806,10 @@
           </a:solidFill>
           <a:ln/>
         </p:spPr>
+        <p:txBody>
+          <a:bodyPr/>
+          <a:p/>
+        </p:txBody>
       </p:sp>
       <p:sp>
         <p:nvSpPr>
@@ -12662,6 +13022,10 @@
           </a:solidFill>
           <a:ln/>
         </p:spPr>
+        <p:txBody>
+          <a:bodyPr/>
+          <a:p/>
+        </p:txBody>
       </p:sp>
       <p:sp>
         <p:nvSpPr>
@@ -12723,6 +13087,10 @@
           </a:solidFill>
           <a:ln/>
         </p:spPr>
+        <p:txBody>
+          <a:bodyPr/>
+          <a:p/>
+        </p:txBody>
       </p:sp>
       <p:sp>
         <p:nvSpPr>
@@ -12823,6 +13191,10 @@
           </a:solidFill>
           <a:ln/>
         </p:spPr>
+        <p:txBody>
+          <a:bodyPr/>
+          <a:p/>
+        </p:txBody>
       </p:sp>
       <p:sp>
         <p:nvSpPr>
@@ -12843,6 +13215,10 @@
           </a:solidFill>
           <a:ln/>
         </p:spPr>
+        <p:txBody>
+          <a:bodyPr/>
+          <a:p/>
+        </p:txBody>
       </p:sp>
       <p:sp>
         <p:nvSpPr>
@@ -12904,6 +13280,10 @@
           </a:solidFill>
           <a:ln/>
         </p:spPr>
+        <p:txBody>
+          <a:bodyPr/>
+          <a:p/>
+        </p:txBody>
       </p:sp>
       <p:sp>
         <p:nvSpPr>
@@ -12924,6 +13304,10 @@
           </a:solidFill>
           <a:ln/>
         </p:spPr>
+        <p:txBody>
+          <a:bodyPr/>
+          <a:p/>
+        </p:txBody>
       </p:sp>
       <p:sp>
         <p:nvSpPr>
@@ -12985,6 +13369,10 @@
           </a:solidFill>
           <a:ln/>
         </p:spPr>
+        <p:txBody>
+          <a:bodyPr/>
+          <a:p/>
+        </p:txBody>
       </p:sp>
       <p:sp>
         <p:nvSpPr>
@@ -13005,6 +13393,10 @@
           </a:solidFill>
           <a:ln/>
         </p:spPr>
+        <p:txBody>
+          <a:bodyPr/>
+          <a:p/>
+        </p:txBody>
       </p:sp>
       <p:sp>
         <p:nvSpPr>
@@ -13105,6 +13497,10 @@
           </a:solidFill>
           <a:ln/>
         </p:spPr>
+        <p:txBody>
+          <a:bodyPr/>
+          <a:p/>
+        </p:txBody>
       </p:sp>
       <p:sp>
         <p:nvSpPr>
@@ -13275,6 +13671,10 @@
           </a:solidFill>
           <a:ln/>
         </p:spPr>
+        <p:txBody>
+          <a:bodyPr/>
+          <a:p/>
+        </p:txBody>
       </p:sp>
       <p:sp>
         <p:nvSpPr>
@@ -13348,7 +13748,7 @@
                 <a:ea typeface="Microsoft JhengHei" pitchFamily="34" charset="-122"/>
                 <a:cs typeface="Microsoft JhengHei" pitchFamily="34" charset="-120"/>
               </a:rPr>
-              <a:t>兩種部署,一條界線</a:t>
+              <a:t>三種部署,一條資料界線</a:t>
             </a:r>
             <a:endParaRPr lang="en-US" sz="3400" dirty="0"/>
           </a:p>
@@ -13417,6 +13817,10 @@
           </a:solidFill>
           <a:ln/>
         </p:spPr>
+        <p:txBody>
+          <a:bodyPr/>
+          <a:p/>
+        </p:txBody>
       </p:sp>
       <p:sp>
         <p:nvSpPr>
@@ -13437,6 +13841,10 @@
           </a:solidFill>
           <a:ln/>
         </p:spPr>
+        <p:txBody>
+          <a:bodyPr/>
+          <a:p/>
+        </p:txBody>
       </p:sp>
       <p:sp>
         <p:nvSpPr>
@@ -13471,7 +13879,7 @@
                 <a:ea typeface="Arial" pitchFamily="34" charset="-122"/>
                 <a:cs typeface="Arial" pitchFamily="34" charset="-120"/>
               </a:rPr>
-              <a:t>Phase 1 · Hosted</a:t>
+              <a:t>Hosted remote</a:t>
             </a:r>
             <a:endParaRPr lang="en-US" sz="1600" dirty="0"/>
           </a:p>
@@ -13537,6 +13945,10 @@
           </a:solidFill>
           <a:ln/>
         </p:spPr>
+        <p:txBody>
+          <a:bodyPr/>
+          <a:p/>
+        </p:txBody>
       </p:sp>
       <p:sp>
         <p:nvSpPr>
@@ -13557,6 +13969,10 @@
           </a:solidFill>
           <a:ln/>
         </p:spPr>
+        <p:txBody>
+          <a:bodyPr/>
+          <a:p/>
+        </p:txBody>
       </p:sp>
       <p:sp>
         <p:nvSpPr>
@@ -13591,7 +14007,7 @@
                 <a:ea typeface="Arial" pitchFamily="34" charset="-122"/>
                 <a:cs typeface="Arial" pitchFamily="34" charset="-120"/>
               </a:rPr>
-              <a:t>Phase 1 的界線</a:t>
+              <a:t>Hosted 的界線</a:t>
             </a:r>
             <a:endParaRPr lang="en-US" sz="1600" dirty="0"/>
           </a:p>
@@ -13657,6 +14073,10 @@
           </a:solidFill>
           <a:ln/>
         </p:spPr>
+        <p:txBody>
+          <a:bodyPr/>
+          <a:p/>
+        </p:txBody>
       </p:sp>
       <p:sp>
         <p:nvSpPr>
@@ -13677,6 +14097,10 @@
           </a:solidFill>
           <a:ln/>
         </p:spPr>
+        <p:txBody>
+          <a:bodyPr/>
+          <a:p/>
+        </p:txBody>
       </p:sp>
       <p:sp>
         <p:nvSpPr>
@@ -13711,7 +14135,7 @@
                 <a:ea typeface="Arial" pitchFamily="34" charset="-122"/>
                 <a:cs typeface="Arial" pitchFamily="34" charset="-120"/>
               </a:rPr>
-              <a:t>Phase 2 · 使用者環境</a:t>
+              <a:t>Local / private</a:t>
             </a:r>
             <a:endParaRPr lang="en-US" sz="1600" dirty="0"/>
           </a:p>
@@ -13777,6 +14201,10 @@
           </a:solidFill>
           <a:ln/>
         </p:spPr>
+        <p:txBody>
+          <a:bodyPr/>
+          <a:p/>
+        </p:txBody>
       </p:sp>
       <p:sp>
         <p:nvSpPr>
@@ -13797,6 +14225,10 @@
           </a:solidFill>
           <a:ln/>
         </p:spPr>
+        <p:txBody>
+          <a:bodyPr/>
+          <a:p/>
+        </p:txBody>
       </p:sp>
       <p:sp>
         <p:nvSpPr>
@@ -13831,7 +14263,7 @@
                 <a:ea typeface="Arial" pitchFamily="34" charset="-122"/>
                 <a:cs typeface="Arial" pitchFamily="34" charset="-120"/>
               </a:rPr>
-              <a:t>Phase 2 是主線</a:t>
+              <a:t>Private data plane</a:t>
             </a:r>
             <a:endParaRPr lang="en-US" sz="1600" dirty="0"/>
           </a:p>
@@ -13870,7 +14302,7 @@
                 <a:ea typeface="Microsoft JhengHei" pitchFamily="34" charset="-122"/>
                 <a:cs typeface="Microsoft JhengHei" pitchFamily="34" charset="-120"/>
               </a:rPr>
-              <a:t>只有它能做到 Claude 也看不見原始資料</a:t>
+              <a:t>只有 user-controlled private 能做到原始資料不離開控制邊界</a:t>
             </a:r>
             <a:endParaRPr lang="en-US" sz="1300" dirty="0"/>
           </a:p>
@@ -13967,6 +14399,10 @@
           </a:solidFill>
           <a:ln/>
         </p:spPr>
+        <p:txBody>
+          <a:bodyPr/>
+          <a:p/>
+        </p:txBody>
       </p:sp>
       <p:sp>
         <p:nvSpPr>
@@ -14109,6 +14545,10 @@
           </a:solidFill>
           <a:ln/>
         </p:spPr>
+        <p:txBody>
+          <a:bodyPr/>
+          <a:p/>
+        </p:txBody>
       </p:sp>
       <p:sp>
         <p:nvSpPr>
@@ -14129,6 +14569,10 @@
           </a:solidFill>
           <a:ln/>
         </p:spPr>
+        <p:txBody>
+          <a:bodyPr/>
+          <a:p/>
+        </p:txBody>
       </p:sp>
       <p:sp>
         <p:nvSpPr>
@@ -14232,6 +14676,10 @@
           </a:solidFill>
           <a:ln/>
         </p:spPr>
+        <p:txBody>
+          <a:bodyPr/>
+          <a:p/>
+        </p:txBody>
       </p:sp>
       <p:sp>
         <p:nvSpPr>
@@ -14252,6 +14700,10 @@
           </a:solidFill>
           <a:ln/>
         </p:spPr>
+        <p:txBody>
+          <a:bodyPr/>
+          <a:p/>
+        </p:txBody>
       </p:sp>
       <p:sp>
         <p:nvSpPr>
@@ -14355,6 +14807,10 @@
           </a:solidFill>
           <a:ln/>
         </p:spPr>
+        <p:txBody>
+          <a:bodyPr/>
+          <a:p/>
+        </p:txBody>
       </p:sp>
       <p:sp>
         <p:nvSpPr>
@@ -14375,6 +14831,10 @@
           </a:solidFill>
           <a:ln/>
         </p:spPr>
+        <p:txBody>
+          <a:bodyPr/>
+          <a:p/>
+        </p:txBody>
       </p:sp>
       <p:sp>
         <p:nvSpPr>
@@ -14478,6 +14938,10 @@
           </a:solidFill>
           <a:ln/>
         </p:spPr>
+        <p:txBody>
+          <a:bodyPr/>
+          <a:p/>
+        </p:txBody>
       </p:sp>
       <p:sp>
         <p:nvSpPr>
@@ -14498,6 +14962,10 @@
           </a:solidFill>
           <a:ln/>
         </p:spPr>
+        <p:txBody>
+          <a:bodyPr/>
+          <a:p/>
+        </p:txBody>
       </p:sp>
       <p:sp>
         <p:nvSpPr>
@@ -14601,6 +15069,10 @@
           </a:solidFill>
           <a:ln/>
         </p:spPr>
+        <p:txBody>
+          <a:bodyPr/>
+          <a:p/>
+        </p:txBody>
       </p:sp>
       <p:sp>
         <p:nvSpPr>
@@ -14621,6 +15093,10 @@
           </a:solidFill>
           <a:ln/>
         </p:spPr>
+        <p:txBody>
+          <a:bodyPr/>
+          <a:p/>
+        </p:txBody>
       </p:sp>
       <p:sp>
         <p:nvSpPr>
@@ -14724,6 +15200,10 @@
           </a:solidFill>
           <a:ln/>
         </p:spPr>
+        <p:txBody>
+          <a:bodyPr/>
+          <a:p/>
+        </p:txBody>
       </p:sp>
       <p:sp>
         <p:nvSpPr>
@@ -14744,6 +15224,10 @@
           </a:solidFill>
           <a:ln/>
         </p:spPr>
+        <p:txBody>
+          <a:bodyPr/>
+          <a:p/>
+        </p:txBody>
       </p:sp>
       <p:sp>
         <p:nvSpPr>
@@ -14917,6 +15401,10 @@
           </a:solidFill>
           <a:ln/>
         </p:spPr>
+        <p:txBody>
+          <a:bodyPr/>
+          <a:p/>
+        </p:txBody>
       </p:sp>
       <p:sp>
         <p:nvSpPr>
@@ -14978,6 +15466,10 @@
           </a:solidFill>
           <a:ln/>
         </p:spPr>
+        <p:txBody>
+          <a:bodyPr/>
+          <a:p/>
+        </p:txBody>
       </p:sp>
       <p:sp>
         <p:nvSpPr>
@@ -15078,6 +15570,10 @@
           </a:solidFill>
           <a:ln/>
         </p:spPr>
+        <p:txBody>
+          <a:bodyPr/>
+          <a:p/>
+        </p:txBody>
       </p:sp>
       <p:sp>
         <p:nvSpPr>
@@ -15098,6 +15594,10 @@
           </a:solidFill>
           <a:ln/>
         </p:spPr>
+        <p:txBody>
+          <a:bodyPr/>
+          <a:p/>
+        </p:txBody>
       </p:sp>
       <p:sp>
         <p:nvSpPr>
@@ -15159,6 +15659,10 @@
           </a:solidFill>
           <a:ln/>
         </p:spPr>
+        <p:txBody>
+          <a:bodyPr/>
+          <a:p/>
+        </p:txBody>
       </p:sp>
       <p:sp>
         <p:nvSpPr>
@@ -15179,6 +15683,10 @@
           </a:solidFill>
           <a:ln/>
         </p:spPr>
+        <p:txBody>
+          <a:bodyPr/>
+          <a:p/>
+        </p:txBody>
       </p:sp>
       <p:sp>
         <p:nvSpPr>
@@ -15240,6 +15748,10 @@
           </a:solidFill>
           <a:ln/>
         </p:spPr>
+        <p:txBody>
+          <a:bodyPr/>
+          <a:p/>
+        </p:txBody>
       </p:sp>
       <p:sp>
         <p:nvSpPr>
@@ -15260,6 +15772,10 @@
           </a:solidFill>
           <a:ln/>
         </p:spPr>
+        <p:txBody>
+          <a:bodyPr/>
+          <a:p/>
+        </p:txBody>
       </p:sp>
       <p:sp>
         <p:nvSpPr>
@@ -15360,6 +15876,10 @@
           </a:solidFill>
           <a:ln/>
         </p:spPr>
+        <p:txBody>
+          <a:bodyPr/>
+          <a:p/>
+        </p:txBody>
       </p:sp>
       <p:sp>
         <p:nvSpPr>
@@ -15569,6 +16089,10 @@
           </a:solidFill>
           <a:ln/>
         </p:spPr>
+        <p:txBody>
+          <a:bodyPr/>
+          <a:p/>
+        </p:txBody>
       </p:sp>
       <p:sp>
         <p:nvSpPr>
@@ -15630,6 +16154,10 @@
           </a:solidFill>
           <a:ln/>
         </p:spPr>
+        <p:txBody>
+          <a:bodyPr/>
+          <a:p/>
+        </p:txBody>
       </p:sp>
       <p:sp>
         <p:nvSpPr>
@@ -15730,6 +16258,10 @@
           </a:solidFill>
           <a:ln/>
         </p:spPr>
+        <p:txBody>
+          <a:bodyPr/>
+          <a:p/>
+        </p:txBody>
       </p:sp>
       <p:sp>
         <p:nvSpPr>
@@ -15750,6 +16282,10 @@
           </a:solidFill>
           <a:ln/>
         </p:spPr>
+        <p:txBody>
+          <a:bodyPr/>
+          <a:p/>
+        </p:txBody>
       </p:sp>
       <p:sp>
         <p:nvSpPr>
@@ -15811,6 +16347,10 @@
           </a:solidFill>
           <a:ln/>
         </p:spPr>
+        <p:txBody>
+          <a:bodyPr/>
+          <a:p/>
+        </p:txBody>
       </p:sp>
       <p:sp>
         <p:nvSpPr>
@@ -15831,6 +16371,10 @@
           </a:solidFill>
           <a:ln/>
         </p:spPr>
+        <p:txBody>
+          <a:bodyPr/>
+          <a:p/>
+        </p:txBody>
       </p:sp>
       <p:sp>
         <p:nvSpPr>
@@ -15892,6 +16436,10 @@
           </a:solidFill>
           <a:ln/>
         </p:spPr>
+        <p:txBody>
+          <a:bodyPr/>
+          <a:p/>
+        </p:txBody>
       </p:sp>
       <p:sp>
         <p:nvSpPr>
@@ -15912,6 +16460,10 @@
           </a:solidFill>
           <a:ln/>
         </p:spPr>
+        <p:txBody>
+          <a:bodyPr/>
+          <a:p/>
+        </p:txBody>
       </p:sp>
       <p:sp>
         <p:nvSpPr>
@@ -16012,6 +16564,10 @@
           </a:solidFill>
           <a:ln/>
         </p:spPr>
+        <p:txBody>
+          <a:bodyPr/>
+          <a:p/>
+        </p:txBody>
       </p:sp>
       <p:sp>
         <p:nvSpPr>
@@ -16221,6 +16777,10 @@
           </a:solidFill>
           <a:ln/>
         </p:spPr>
+        <p:txBody>
+          <a:bodyPr/>
+          <a:p/>
+        </p:txBody>
       </p:sp>
       <p:sp>
         <p:nvSpPr>
@@ -16282,6 +16842,10 @@
           </a:solidFill>
           <a:ln/>
         </p:spPr>
+        <p:txBody>
+          <a:bodyPr/>
+          <a:p/>
+        </p:txBody>
       </p:sp>
       <p:sp>
         <p:nvSpPr>
@@ -16382,6 +16946,10 @@
           </a:solidFill>
           <a:ln/>
         </p:spPr>
+        <p:txBody>
+          <a:bodyPr/>
+          <a:p/>
+        </p:txBody>
       </p:sp>
       <p:sp>
         <p:nvSpPr>
@@ -16402,6 +16970,10 @@
           </a:solidFill>
           <a:ln/>
         </p:spPr>
+        <p:txBody>
+          <a:bodyPr/>
+          <a:p/>
+        </p:txBody>
       </p:sp>
       <p:sp>
         <p:nvSpPr>
@@ -16463,6 +17035,10 @@
           </a:solidFill>
           <a:ln/>
         </p:spPr>
+        <p:txBody>
+          <a:bodyPr/>
+          <a:p/>
+        </p:txBody>
       </p:sp>
       <p:sp>
         <p:nvSpPr>
@@ -16483,6 +17059,10 @@
           </a:solidFill>
           <a:ln/>
         </p:spPr>
+        <p:txBody>
+          <a:bodyPr/>
+          <a:p/>
+        </p:txBody>
       </p:sp>
       <p:sp>
         <p:nvSpPr>
@@ -16544,6 +17124,10 @@
           </a:solidFill>
           <a:ln/>
         </p:spPr>
+        <p:txBody>
+          <a:bodyPr/>
+          <a:p/>
+        </p:txBody>
       </p:sp>
       <p:sp>
         <p:nvSpPr>
@@ -16564,6 +17148,10 @@
           </a:solidFill>
           <a:ln/>
         </p:spPr>
+        <p:txBody>
+          <a:bodyPr/>
+          <a:p/>
+        </p:txBody>
       </p:sp>
       <p:sp>
         <p:nvSpPr>
@@ -16664,6 +17252,10 @@
           </a:solidFill>
           <a:ln/>
         </p:spPr>
+        <p:txBody>
+          <a:bodyPr/>
+          <a:p/>
+        </p:txBody>
       </p:sp>
       <p:sp>
         <p:nvSpPr>
@@ -16834,6 +17426,10 @@
           </a:solidFill>
           <a:ln/>
         </p:spPr>
+        <p:txBody>
+          <a:bodyPr/>
+          <a:p/>
+        </p:txBody>
       </p:sp>
       <p:sp>
         <p:nvSpPr>
@@ -16895,6 +17491,10 @@
           </a:solidFill>
           <a:ln/>
         </p:spPr>
+        <p:txBody>
+          <a:bodyPr/>
+          <a:p/>
+        </p:txBody>
       </p:sp>
       <p:sp>
         <p:nvSpPr>
@@ -16995,6 +17595,10 @@
           </a:solidFill>
           <a:ln/>
         </p:spPr>
+        <p:txBody>
+          <a:bodyPr/>
+          <a:p/>
+        </p:txBody>
       </p:sp>
       <p:sp>
         <p:nvSpPr>
@@ -17015,6 +17619,10 @@
           </a:solidFill>
           <a:ln/>
         </p:spPr>
+        <p:txBody>
+          <a:bodyPr/>
+          <a:p/>
+        </p:txBody>
       </p:sp>
       <p:sp>
         <p:nvSpPr>
@@ -17076,6 +17684,10 @@
           </a:solidFill>
           <a:ln/>
         </p:spPr>
+        <p:txBody>
+          <a:bodyPr/>
+          <a:p/>
+        </p:txBody>
       </p:sp>
       <p:sp>
         <p:nvSpPr>
@@ -17096,6 +17708,10 @@
           </a:solidFill>
           <a:ln/>
         </p:spPr>
+        <p:txBody>
+          <a:bodyPr/>
+          <a:p/>
+        </p:txBody>
       </p:sp>
       <p:sp>
         <p:nvSpPr>
@@ -17157,6 +17773,10 @@
           </a:solidFill>
           <a:ln/>
         </p:spPr>
+        <p:txBody>
+          <a:bodyPr/>
+          <a:p/>
+        </p:txBody>
       </p:sp>
       <p:sp>
         <p:nvSpPr>
@@ -17177,6 +17797,10 @@
           </a:solidFill>
           <a:ln/>
         </p:spPr>
+        <p:txBody>
+          <a:bodyPr/>
+          <a:p/>
+        </p:txBody>
       </p:sp>
       <p:sp>
         <p:nvSpPr>
@@ -17277,6 +17901,10 @@
           </a:solidFill>
           <a:ln/>
         </p:spPr>
+        <p:txBody>
+          <a:bodyPr/>
+          <a:p/>
+        </p:txBody>
       </p:sp>
       <p:sp>
         <p:nvSpPr>
@@ -17486,6 +18114,10 @@
           </a:solidFill>
           <a:ln/>
         </p:spPr>
+        <p:txBody>
+          <a:bodyPr/>
+          <a:p/>
+        </p:txBody>
       </p:sp>
       <p:sp>
         <p:nvSpPr>
@@ -17547,6 +18179,10 @@
           </a:solidFill>
           <a:ln/>
         </p:spPr>
+        <p:txBody>
+          <a:bodyPr/>
+          <a:p/>
+        </p:txBody>
       </p:sp>
       <p:sp>
         <p:nvSpPr>
@@ -17647,6 +18283,10 @@
           </a:solidFill>
           <a:ln/>
         </p:spPr>
+        <p:txBody>
+          <a:bodyPr/>
+          <a:p/>
+        </p:txBody>
       </p:sp>
       <p:sp>
         <p:nvSpPr>
@@ -17667,6 +18307,10 @@
           </a:solidFill>
           <a:ln/>
         </p:spPr>
+        <p:txBody>
+          <a:bodyPr/>
+          <a:p/>
+        </p:txBody>
       </p:sp>
       <p:sp>
         <p:nvSpPr>
@@ -17728,6 +18372,10 @@
           </a:solidFill>
           <a:ln/>
         </p:spPr>
+        <p:txBody>
+          <a:bodyPr/>
+          <a:p/>
+        </p:txBody>
       </p:sp>
       <p:sp>
         <p:nvSpPr>
@@ -17748,6 +18396,10 @@
           </a:solidFill>
           <a:ln/>
         </p:spPr>
+        <p:txBody>
+          <a:bodyPr/>
+          <a:p/>
+        </p:txBody>
       </p:sp>
       <p:sp>
         <p:nvSpPr>
@@ -17809,6 +18461,10 @@
           </a:solidFill>
           <a:ln/>
         </p:spPr>
+        <p:txBody>
+          <a:bodyPr/>
+          <a:p/>
+        </p:txBody>
       </p:sp>
       <p:sp>
         <p:nvSpPr>
@@ -17829,6 +18485,10 @@
           </a:solidFill>
           <a:ln/>
         </p:spPr>
+        <p:txBody>
+          <a:bodyPr/>
+          <a:p/>
+        </p:txBody>
       </p:sp>
       <p:sp>
         <p:nvSpPr>
@@ -17929,6 +18589,10 @@
           </a:solidFill>
           <a:ln/>
         </p:spPr>
+        <p:txBody>
+          <a:bodyPr/>
+          <a:p/>
+        </p:txBody>
       </p:sp>
       <p:sp>
         <p:nvSpPr>
@@ -18099,6 +18763,10 @@
           </a:solidFill>
           <a:ln/>
         </p:spPr>
+        <p:txBody>
+          <a:bodyPr/>
+          <a:p/>
+        </p:txBody>
       </p:sp>
       <p:sp>
         <p:nvSpPr>
@@ -18160,6 +18828,10 @@
           </a:solidFill>
           <a:ln/>
         </p:spPr>
+        <p:txBody>
+          <a:bodyPr/>
+          <a:p/>
+        </p:txBody>
       </p:sp>
       <p:sp>
         <p:nvSpPr>
@@ -18260,6 +18932,10 @@
           </a:solidFill>
           <a:ln/>
         </p:spPr>
+        <p:txBody>
+          <a:bodyPr/>
+          <a:p/>
+        </p:txBody>
       </p:sp>
       <p:sp>
         <p:nvSpPr>
@@ -18280,6 +18956,10 @@
           </a:solidFill>
           <a:ln/>
         </p:spPr>
+        <p:txBody>
+          <a:bodyPr/>
+          <a:p/>
+        </p:txBody>
       </p:sp>
       <p:sp>
         <p:nvSpPr>
@@ -18341,6 +19021,10 @@
           </a:solidFill>
           <a:ln/>
         </p:spPr>
+        <p:txBody>
+          <a:bodyPr/>
+          <a:p/>
+        </p:txBody>
       </p:sp>
       <p:sp>
         <p:nvSpPr>
@@ -18361,6 +19045,10 @@
           </a:solidFill>
           <a:ln/>
         </p:spPr>
+        <p:txBody>
+          <a:bodyPr/>
+          <a:p/>
+        </p:txBody>
       </p:sp>
       <p:sp>
         <p:nvSpPr>
@@ -18422,6 +19110,10 @@
           </a:solidFill>
           <a:ln/>
         </p:spPr>
+        <p:txBody>
+          <a:bodyPr/>
+          <a:p/>
+        </p:txBody>
       </p:sp>
       <p:sp>
         <p:nvSpPr>
@@ -18442,6 +19134,10 @@
           </a:solidFill>
           <a:ln/>
         </p:spPr>
+        <p:txBody>
+          <a:bodyPr/>
+          <a:p/>
+        </p:txBody>
       </p:sp>
       <p:sp>
         <p:nvSpPr>
@@ -18542,6 +19238,10 @@
           </a:solidFill>
           <a:ln/>
         </p:spPr>
+        <p:txBody>
+          <a:bodyPr/>
+          <a:p/>
+        </p:txBody>
       </p:sp>
       <p:sp>
         <p:nvSpPr>
@@ -18712,6 +19412,10 @@
           </a:solidFill>
           <a:ln/>
         </p:spPr>
+        <p:txBody>
+          <a:bodyPr/>
+          <a:p/>
+        </p:txBody>
       </p:sp>
       <p:sp>
         <p:nvSpPr>
@@ -18854,6 +19558,10 @@
           </a:solidFill>
           <a:ln/>
         </p:spPr>
+        <p:txBody>
+          <a:bodyPr/>
+          <a:p/>
+        </p:txBody>
       </p:sp>
       <p:sp>
         <p:nvSpPr>
@@ -18957,6 +19665,10 @@
           </a:solidFill>
           <a:ln/>
         </p:spPr>
+        <p:txBody>
+          <a:bodyPr/>
+          <a:p/>
+        </p:txBody>
       </p:sp>
       <p:sp>
         <p:nvSpPr>
@@ -19169,6 +19881,10 @@
           </a:solidFill>
           <a:ln/>
         </p:spPr>
+        <p:txBody>
+          <a:bodyPr/>
+          <a:p/>
+        </p:txBody>
       </p:sp>
       <p:sp>
         <p:nvSpPr>
@@ -19311,6 +20027,10 @@
           </a:solidFill>
           <a:ln/>
         </p:spPr>
+        <p:txBody>
+          <a:bodyPr/>
+          <a:p/>
+        </p:txBody>
       </p:sp>
       <p:sp>
         <p:nvSpPr>
@@ -19414,6 +20134,10 @@
           </a:solidFill>
           <a:ln/>
         </p:spPr>
+        <p:txBody>
+          <a:bodyPr/>
+          <a:p/>
+        </p:txBody>
       </p:sp>
       <p:sp>
         <p:nvSpPr>
@@ -19517,6 +20241,10 @@
           </a:solidFill>
           <a:ln/>
         </p:spPr>
+        <p:txBody>
+          <a:bodyPr/>
+          <a:p/>
+        </p:txBody>
       </p:sp>
       <p:sp>
         <p:nvSpPr>
@@ -19620,6 +20348,10 @@
           </a:solidFill>
           <a:ln/>
         </p:spPr>
+        <p:txBody>
+          <a:bodyPr/>
+          <a:p/>
+        </p:txBody>
       </p:sp>
       <p:sp>
         <p:nvSpPr>
@@ -19832,6 +20564,10 @@
           </a:solidFill>
           <a:ln/>
         </p:spPr>
+        <p:txBody>
+          <a:bodyPr/>
+          <a:p/>
+        </p:txBody>
       </p:sp>
       <p:sp>
         <p:nvSpPr>
@@ -19974,6 +20710,10 @@
           </a:solidFill>
           <a:ln/>
         </p:spPr>
+        <p:txBody>
+          <a:bodyPr/>
+          <a:p/>
+        </p:txBody>
       </p:sp>
       <p:sp>
         <p:nvSpPr>
@@ -19994,6 +20734,10 @@
           </a:solidFill>
           <a:ln/>
         </p:spPr>
+        <p:txBody>
+          <a:bodyPr/>
+          <a:p/>
+        </p:txBody>
       </p:sp>
       <p:sp>
         <p:nvSpPr>
@@ -20106,7 +20850,7 @@
                 <a:ea typeface="Microsoft JhengHei" pitchFamily="34" charset="-122"/>
                 <a:cs typeface="Microsoft JhengHei" pitchFamily="34" charset="-120"/>
               </a:rPr>
-              <a:t>Apple Health／Garmin／Google／Strava</a:t>
+              <a:t>Apple Health／Garmin／Google／Strava／Oura／WHOOP／Oura／WHOOP</a:t>
             </a:r>
             <a:endParaRPr lang="en-US" sz="1050" dirty="0"/>
           </a:p>
@@ -20134,6 +20878,10 @@
             <a:prstDash val="solid"/>
           </a:ln>
         </p:spPr>
+        <p:txBody>
+          <a:bodyPr/>
+          <a:p/>
+        </p:txBody>
       </p:sp>
       <p:sp>
         <p:nvSpPr>
@@ -20168,7 +20916,7 @@
                 <a:ea typeface="Microsoft JhengHei" pitchFamily="34" charset="-122"/>
                 <a:cs typeface="Microsoft JhengHei" pitchFamily="34" charset="-120"/>
               </a:rPr>
-              <a:t>現況  4 家 parser,registry 6 家</a:t>
+              <a:t>現況  6 家 parser,registry 6 家（8 種方言）</a:t>
             </a:r>
             <a:endParaRPr lang="en-US" sz="1000" dirty="0"/>
           </a:p>
@@ -20195,6 +20943,10 @@
           </a:solidFill>
           <a:ln/>
         </p:spPr>
+        <p:txBody>
+          <a:bodyPr/>
+          <a:p/>
+        </p:txBody>
       </p:sp>
       <p:sp>
         <p:nvSpPr>
@@ -20215,6 +20967,10 @@
           </a:solidFill>
           <a:ln/>
         </p:spPr>
+        <p:txBody>
+          <a:bodyPr/>
+          <a:p/>
+        </p:txBody>
       </p:sp>
       <p:sp>
         <p:nvSpPr>
@@ -20355,6 +21111,10 @@
             <a:prstDash val="solid"/>
           </a:ln>
         </p:spPr>
+        <p:txBody>
+          <a:bodyPr/>
+          <a:p/>
+        </p:txBody>
       </p:sp>
       <p:sp>
         <p:nvSpPr>
@@ -20389,7 +21149,7 @@
                 <a:ea typeface="Microsoft JhengHei" pitchFamily="34" charset="-122"/>
                 <a:cs typeface="Microsoft JhengHei" pitchFamily="34" charset="-120"/>
               </a:rPr>
-              <a:t>現況  300 tests、20 golden cases 全綠</a:t>
+              <a:t>現況  470 tests、20 golden cases 全綠</a:t>
             </a:r>
             <a:endParaRPr lang="en-US" sz="1000" dirty="0"/>
           </a:p>
@@ -20416,6 +21176,10 @@
           </a:solidFill>
           <a:ln/>
         </p:spPr>
+        <p:txBody>
+          <a:bodyPr/>
+          <a:p/>
+        </p:txBody>
       </p:sp>
       <p:sp>
         <p:nvSpPr>
@@ -20436,6 +21200,10 @@
           </a:solidFill>
           <a:ln/>
         </p:spPr>
+        <p:txBody>
+          <a:bodyPr/>
+          <a:p/>
+        </p:txBody>
       </p:sp>
       <p:sp>
         <p:nvSpPr>
@@ -20576,6 +21344,10 @@
             <a:prstDash val="solid"/>
           </a:ln>
         </p:spPr>
+        <p:txBody>
+          <a:bodyPr/>
+          <a:p/>
+        </p:txBody>
       </p:sp>
       <p:sp>
         <p:nvSpPr>
@@ -20637,6 +21409,10 @@
           </a:solidFill>
           <a:ln/>
         </p:spPr>
+        <p:txBody>
+          <a:bodyPr/>
+          <a:p/>
+        </p:txBody>
       </p:sp>
       <p:sp>
         <p:nvSpPr>
@@ -20657,6 +21433,10 @@
           </a:solidFill>
           <a:ln/>
         </p:spPr>
+        <p:txBody>
+          <a:bodyPr/>
+          <a:p/>
+        </p:txBody>
       </p:sp>
       <p:sp>
         <p:nvSpPr>
@@ -20797,6 +21577,10 @@
             <a:prstDash val="solid"/>
           </a:ln>
         </p:spPr>
+        <p:txBody>
+          <a:bodyPr/>
+          <a:p/>
+        </p:txBody>
       </p:sp>
       <p:sp>
         <p:nvSpPr>
@@ -20858,6 +21642,10 @@
           </a:solidFill>
           <a:ln/>
         </p:spPr>
+        <p:txBody>
+          <a:bodyPr/>
+          <a:p/>
+        </p:txBody>
       </p:sp>
       <p:sp>
         <p:nvSpPr>
@@ -20878,6 +21666,10 @@
           </a:solidFill>
           <a:ln/>
         </p:spPr>
+        <p:txBody>
+          <a:bodyPr/>
+          <a:p/>
+        </p:txBody>
       </p:sp>
       <p:sp>
         <p:nvSpPr>
@@ -21018,6 +21810,10 @@
             <a:prstDash val="solid"/>
           </a:ln>
         </p:spPr>
+        <p:txBody>
+          <a:bodyPr/>
+          <a:p/>
+        </p:txBody>
       </p:sp>
       <p:sp>
         <p:nvSpPr>
@@ -21052,7 +21848,7 @@
                 <a:ea typeface="Microsoft JhengHei" pitchFamily="34" charset="-122"/>
                 <a:cs typeface="Microsoft JhengHei" pitchFamily="34" charset="-120"/>
               </a:rPr>
-              <a:t>待做  驗證器未填,沒有 AS</a:t>
+              <a:t>現況  private-development adapter；待做 production authorization server</a:t>
             </a:r>
             <a:endParaRPr lang="en-US" sz="1000" dirty="0"/>
           </a:p>
@@ -21079,6 +21875,10 @@
           </a:solidFill>
           <a:ln/>
         </p:spPr>
+        <p:txBody>
+          <a:bodyPr/>
+          <a:p/>
+        </p:txBody>
       </p:sp>
       <p:sp>
         <p:nvSpPr>
@@ -21099,6 +21899,10 @@
           </a:solidFill>
           <a:ln/>
         </p:spPr>
+        <p:txBody>
+          <a:bodyPr/>
+          <a:p/>
+        </p:txBody>
       </p:sp>
       <p:sp>
         <p:nvSpPr>
@@ -21239,6 +22043,10 @@
             <a:prstDash val="solid"/>
           </a:ln>
         </p:spPr>
+        <p:txBody>
+          <a:bodyPr/>
+          <a:p/>
+        </p:txBody>
       </p:sp>
       <p:sp>
         <p:nvSpPr>
@@ -21300,6 +22108,10 @@
           </a:solidFill>
           <a:ln/>
         </p:spPr>
+        <p:txBody>
+          <a:bodyPr/>
+          <a:p/>
+        </p:txBody>
       </p:sp>
       <p:sp>
         <p:nvSpPr>
@@ -21320,6 +22132,10 @@
           </a:solidFill>
           <a:ln/>
         </p:spPr>
+        <p:txBody>
+          <a:bodyPr/>
+          <a:p/>
+        </p:txBody>
       </p:sp>
       <p:sp>
         <p:nvSpPr>
@@ -21393,7 +22209,7 @@
                 <a:ea typeface="Microsoft JhengHei" pitchFamily="34" charset="-122"/>
                 <a:cs typeface="Microsoft JhengHei" pitchFamily="34" charset="-120"/>
               </a:rPr>
-              <a:t>Phase 2 local engine</a:t>
+              <a:t>User-controlled private engine</a:t>
             </a:r>
             <a:endParaRPr lang="en-US" sz="1300" dirty="0"/>
           </a:p>
@@ -21460,6 +22276,10 @@
             <a:prstDash val="solid"/>
           </a:ln>
         </p:spPr>
+        <p:txBody>
+          <a:bodyPr/>
+          <a:p/>
+        </p:txBody>
       </p:sp>
       <p:sp>
         <p:nvSpPr>
@@ -21494,7 +22314,7 @@
                 <a:ea typeface="Microsoft JhengHei" pitchFamily="34" charset="-122"/>
                 <a:cs typeface="Microsoft JhengHei" pitchFamily="34" charset="-120"/>
               </a:rPr>
-              <a:t>待做  一行程式都沒有</a:t>
+              <a:t>待做  local bundle／持久層／connector 權限</a:t>
             </a:r>
             <a:endParaRPr lang="en-US" sz="1000" dirty="0"/>
           </a:p>
@@ -21521,6 +22341,10 @@
           </a:solidFill>
           <a:ln/>
         </p:spPr>
+        <p:txBody>
+          <a:bodyPr/>
+          <a:p/>
+        </p:txBody>
       </p:sp>
       <p:sp>
         <p:nvSpPr>
@@ -21541,6 +22365,10 @@
           </a:solidFill>
           <a:ln/>
         </p:spPr>
+        <p:txBody>
+          <a:bodyPr/>
+          <a:p/>
+        </p:txBody>
       </p:sp>
       <p:sp>
         <p:nvSpPr>
@@ -21681,6 +22509,10 @@
             <a:prstDash val="solid"/>
           </a:ln>
         </p:spPr>
+        <p:txBody>
+          <a:bodyPr/>
+          <a:p/>
+        </p:txBody>
       </p:sp>
       <p:sp>
         <p:nvSpPr>
@@ -21742,6 +22574,10 @@
           </a:solidFill>
           <a:ln/>
         </p:spPr>
+        <p:txBody>
+          <a:bodyPr/>
+          <a:p/>
+        </p:txBody>
       </p:sp>
       <p:sp>
         <p:nvSpPr>
@@ -21762,6 +22598,10 @@
           </a:solidFill>
           <a:ln/>
         </p:spPr>
+        <p:txBody>
+          <a:bodyPr/>
+          <a:p/>
+        </p:txBody>
       </p:sp>
       <p:sp>
         <p:nvSpPr>
@@ -21902,6 +22742,10 @@
             <a:prstDash val="solid"/>
           </a:ln>
         </p:spPr>
+        <p:txBody>
+          <a:bodyPr/>
+          <a:p/>
+        </p:txBody>
       </p:sp>
       <p:sp>
         <p:nvSpPr>
@@ -22033,6 +22877,10 @@
           </a:solidFill>
           <a:ln/>
         </p:spPr>
+        <p:txBody>
+          <a:bodyPr/>
+          <a:p/>
+        </p:txBody>
       </p:sp>
       <p:sp>
         <p:nvSpPr>
@@ -22148,7 +22996,7 @@
                 <a:ea typeface="Microsoft JhengHei" pitchFamily="34" charset="-122"/>
                 <a:cs typeface="Microsoft JhengHei" pitchFamily="34" charset="-120"/>
               </a:rPr>
-              <a:t>我們要的是運動領域的同一個位置:資料整合 + AI 規劃 + MCP 的基礎層。</a:t>
+              <a:t>我們要的是運動領域的決策基礎層:證據、規則與可追溯的 from → to。</a:t>
             </a:r>
             <a:endParaRPr lang="en-US" sz="2000" dirty="0"/>
           </a:p>
@@ -22175,6 +23023,10 @@
           </a:solidFill>
           <a:ln/>
         </p:spPr>
+        <p:txBody>
+          <a:bodyPr/>
+          <a:p/>
+        </p:txBody>
       </p:sp>
       <p:sp>
         <p:nvSpPr>
@@ -22278,6 +23130,10 @@
           </a:solidFill>
           <a:ln/>
         </p:spPr>
+        <p:txBody>
+          <a:bodyPr/>
+          <a:p/>
+        </p:txBody>
       </p:sp>
       <p:sp>
         <p:nvSpPr>
@@ -22381,6 +23237,10 @@
           </a:solidFill>
           <a:ln/>
         </p:spPr>
+        <p:txBody>
+          <a:bodyPr/>
+          <a:p/>
+        </p:txBody>
       </p:sp>
       <p:sp>
         <p:nvSpPr>
@@ -22477,7 +23337,7 @@
                 <a:ea typeface="Microsoft JhengHei" pitchFamily="34" charset="-122"/>
                 <a:cs typeface="Microsoft JhengHei" pitchFamily="34" charset="-120"/>
               </a:rPr>
-              <a:t>Intelligence Layer</a:t>
+              <a:t>Decision Layer</a:t>
             </a:r>
             <a:endParaRPr lang="en-US" sz="1400" dirty="0"/>
           </a:p>
@@ -22516,7 +23376,7 @@
                 <a:ea typeface="Microsoft JhengHei" pitchFamily="34" charset="-122"/>
                 <a:cs typeface="Microsoft JhengHei" pitchFamily="34" charset="-120"/>
               </a:rPr>
-              <a:t>上層可以換成 AR 眼鏡,底層可以換掉任何一家裝置商 —— 中間這一層不用動。</a:t>
+              <a:t>上層可以換成任何 AI host,底層可以換掉任何一家裝置商 —— 中間的決策層不用動。</a:t>
             </a:r>
             <a:endParaRPr lang="en-US" sz="1250" dirty="0"/>
           </a:p>
@@ -22615,6 +23475,10 @@
           </a:solidFill>
           <a:ln/>
         </p:spPr>
+        <p:txBody>
+          <a:bodyPr/>
+          <a:p/>
+        </p:txBody>
       </p:sp>
       <p:sp>
         <p:nvSpPr>
@@ -22635,6 +23499,10 @@
           </a:solidFill>
           <a:ln/>
         </p:spPr>
+        <p:txBody>
+          <a:bodyPr/>
+          <a:p/>
+        </p:txBody>
       </p:sp>
       <p:sp>
         <p:nvSpPr>
@@ -22779,6 +23647,10 @@
             <a:prstDash val="solid"/>
           </a:ln>
         </p:spPr>
+        <p:txBody>
+          <a:bodyPr/>
+          <a:p/>
+        </p:txBody>
       </p:sp>
       <p:sp>
         <p:nvSpPr>
@@ -22813,7 +23685,7 @@
                 <a:ea typeface="Arial" pitchFamily="34" charset="-122"/>
                 <a:cs typeface="Arial" pitchFamily="34" charset="-120"/>
               </a:rPr>
-              <a:t>Evidra — Fitness Decision Engine</a:t>
+              <a:t>Pacevera — Fitness Decision Engine</a:t>
             </a:r>
             <a:endParaRPr lang="en-US" sz="1600" dirty="0"/>
           </a:p>
@@ -22852,7 +23724,7 @@
                 <a:ea typeface="Microsoft JhengHei" pitchFamily="34" charset="-122"/>
                 <a:cs typeface="Microsoft JhengHei" pitchFamily="34" charset="-120"/>
               </a:rPr>
-              <a:t>下一步:送出 desktop extension 上架審查;遠端與 Phase 2 接在後面</a:t>
+              <a:t>下一步:先完成 P0 隱私契約與 P1 local private engine;remote 是後續 access channel,企業私有部署再後續</a:t>
             </a:r>
             <a:endParaRPr lang="en-US" sz="1250" dirty="0"/>
           </a:p>
@@ -22910,6 +23782,10 @@
           </a:solidFill>
           <a:ln/>
         </p:spPr>
+        <p:txBody>
+          <a:bodyPr/>
+          <a:p/>
+        </p:txBody>
       </p:sp>
       <p:sp>
         <p:nvSpPr>
@@ -23052,6 +23928,10 @@
           </a:solidFill>
           <a:ln/>
         </p:spPr>
+        <p:txBody>
+          <a:bodyPr/>
+          <a:p/>
+        </p:txBody>
       </p:sp>
       <p:sp>
         <p:nvSpPr>
@@ -23153,6 +24033,10 @@
             <a:prstDash val="solid"/>
           </a:ln>
         </p:spPr>
+        <p:txBody>
+          <a:bodyPr/>
+          <a:p/>
+        </p:txBody>
       </p:sp>
       <p:sp>
         <p:nvSpPr>
@@ -23214,6 +24098,10 @@
           </a:solidFill>
           <a:ln/>
         </p:spPr>
+        <p:txBody>
+          <a:bodyPr/>
+          <a:p/>
+        </p:txBody>
       </p:sp>
       <p:sp>
         <p:nvSpPr>
@@ -23315,6 +24203,10 @@
             <a:prstDash val="solid"/>
           </a:ln>
         </p:spPr>
+        <p:txBody>
+          <a:bodyPr/>
+          <a:p/>
+        </p:txBody>
       </p:sp>
       <p:sp>
         <p:nvSpPr>
@@ -23376,6 +24268,10 @@
           </a:solidFill>
           <a:ln/>
         </p:spPr>
+        <p:txBody>
+          <a:bodyPr/>
+          <a:p/>
+        </p:txBody>
       </p:sp>
       <p:sp>
         <p:nvSpPr>
@@ -23477,6 +24373,10 @@
             <a:prstDash val="solid"/>
           </a:ln>
         </p:spPr>
+        <p:txBody>
+          <a:bodyPr/>
+          <a:p/>
+        </p:txBody>
       </p:sp>
       <p:sp>
         <p:nvSpPr>
@@ -23608,6 +24508,10 @@
           </a:solidFill>
           <a:ln/>
         </p:spPr>
+        <p:txBody>
+          <a:bodyPr/>
+          <a:p/>
+        </p:txBody>
       </p:sp>
       <p:sp>
         <p:nvSpPr>
@@ -23750,6 +24654,10 @@
           </a:solidFill>
           <a:ln/>
         </p:spPr>
+        <p:txBody>
+          <a:bodyPr/>
+          <a:p/>
+        </p:txBody>
       </p:sp>
       <p:sp>
         <p:nvSpPr>
@@ -23959,6 +24867,10 @@
           </a:solidFill>
           <a:ln/>
         </p:spPr>
+        <p:txBody>
+          <a:bodyPr/>
+          <a:p/>
+        </p:txBody>
       </p:sp>
       <p:sp>
         <p:nvSpPr>
@@ -24101,6 +25013,10 @@
           </a:solidFill>
           <a:ln/>
         </p:spPr>
+        <p:txBody>
+          <a:bodyPr/>
+          <a:p/>
+        </p:txBody>
       </p:sp>
       <p:sp>
         <p:nvSpPr>
@@ -24204,6 +25120,10 @@
           </a:solidFill>
           <a:ln/>
         </p:spPr>
+        <p:txBody>
+          <a:bodyPr/>
+          <a:p/>
+        </p:txBody>
       </p:sp>
       <p:sp>
         <p:nvSpPr>
@@ -24416,6 +25336,10 @@
           </a:solidFill>
           <a:ln/>
         </p:spPr>
+        <p:txBody>
+          <a:bodyPr/>
+          <a:p/>
+        </p:txBody>
       </p:sp>
       <p:sp>
         <p:nvSpPr>
@@ -24558,6 +25482,10 @@
           </a:solidFill>
           <a:ln/>
         </p:spPr>
+        <p:txBody>
+          <a:bodyPr/>
+          <a:p/>
+        </p:txBody>
       </p:sp>
       <p:sp>
         <p:nvSpPr>
@@ -24658,6 +25586,10 @@
           </a:solidFill>
           <a:ln/>
         </p:spPr>
+        <p:txBody>
+          <a:bodyPr/>
+          <a:p/>
+        </p:txBody>
       </p:sp>
       <p:sp>
         <p:nvSpPr>
@@ -24828,6 +25760,10 @@
           </a:solidFill>
           <a:ln/>
         </p:spPr>
+        <p:txBody>
+          <a:bodyPr/>
+          <a:p/>
+        </p:txBody>
       </p:sp>
       <p:sp>
         <p:nvSpPr>
@@ -24970,6 +25906,10 @@
           </a:solidFill>
           <a:ln/>
         </p:spPr>
+        <p:txBody>
+          <a:bodyPr/>
+          <a:p/>
+        </p:txBody>
       </p:sp>
       <p:sp>
         <p:nvSpPr>
@@ -25154,6 +26094,10 @@
           </a:solidFill>
           <a:ln/>
         </p:spPr>
+        <p:txBody>
+          <a:bodyPr/>
+          <a:p/>
+        </p:txBody>
       </p:sp>
       <p:sp>
         <p:nvSpPr>
@@ -25417,6 +26361,10 @@
           </a:solidFill>
           <a:ln/>
         </p:spPr>
+        <p:txBody>
+          <a:bodyPr/>
+          <a:p/>
+        </p:txBody>
       </p:sp>
       <p:sp>
         <p:nvSpPr>
@@ -25559,6 +26507,10 @@
           </a:solidFill>
           <a:ln/>
         </p:spPr>
+        <p:txBody>
+          <a:bodyPr/>
+          <a:p/>
+        </p:txBody>
       </p:sp>
       <p:sp>
         <p:nvSpPr>
@@ -25579,6 +26531,10 @@
           </a:solidFill>
           <a:ln/>
         </p:spPr>
+        <p:txBody>
+          <a:bodyPr/>
+          <a:p/>
+        </p:txBody>
       </p:sp>
       <p:sp>
         <p:nvSpPr>
@@ -25679,6 +26635,10 @@
           </a:solidFill>
           <a:ln/>
         </p:spPr>
+        <p:txBody>
+          <a:bodyPr/>
+          <a:p/>
+        </p:txBody>
       </p:sp>
       <p:sp>
         <p:nvSpPr>
@@ -25699,6 +26659,10 @@
           </a:solidFill>
           <a:ln/>
         </p:spPr>
+        <p:txBody>
+          <a:bodyPr/>
+          <a:p/>
+        </p:txBody>
       </p:sp>
       <p:sp>
         <p:nvSpPr>
@@ -25799,6 +26763,10 @@
           </a:solidFill>
           <a:ln/>
         </p:spPr>
+        <p:txBody>
+          <a:bodyPr/>
+          <a:p/>
+        </p:txBody>
       </p:sp>
       <p:sp>
         <p:nvSpPr>
@@ -25819,6 +26787,10 @@
           </a:solidFill>
           <a:ln/>
         </p:spPr>
+        <p:txBody>
+          <a:bodyPr/>
+          <a:p/>
+        </p:txBody>
       </p:sp>
       <p:sp>
         <p:nvSpPr>
@@ -25919,6 +26891,10 @@
           </a:solidFill>
           <a:ln/>
         </p:spPr>
+        <p:txBody>
+          <a:bodyPr/>
+          <a:p/>
+        </p:txBody>
       </p:sp>
       <p:sp>
         <p:nvSpPr>
@@ -25939,6 +26915,10 @@
           </a:solidFill>
           <a:ln/>
         </p:spPr>
+        <p:txBody>
+          <a:bodyPr/>
+          <a:p/>
+        </p:txBody>
       </p:sp>
       <p:sp>
         <p:nvSpPr>

</xml_diff>

<commit_message>
Complete Phase 0 product and privacy contract
</commit_message>
<xml_diff>
--- a/docs/Fitness-MCP-Product-Vision.pptx
+++ b/docs/Fitness-MCP-Product-Vision.pptx
@@ -3436,7 +3436,7 @@
                 <a:ea typeface="Microsoft JhengHei" pitchFamily="34" charset="-122"/>
                 <a:cs typeface="Microsoft JhengHei" pitchFamily="34" charset="-120"/>
               </a:rPr>
-              <a:t>讓任何 AI 都能做出可重現的訓練決策 —— 而不必看見你完整的原始健康資料。</a:t>
+              <a:t>讓你熟悉的 AI 根據連續 Evidence 做出可重現的訓練決策 —— 健康歷史仍由你控制。</a:t>
             </a:r>
             <a:endParaRPr lang="en-US" sz="1900" dirty="0"/>
           </a:p>
@@ -3502,7 +3502,7 @@
                 <a:ea typeface="Microsoft JhengHei" pitchFamily="34" charset="-122"/>
                 <a:cs typeface="Microsoft JhengHei" pitchFamily="34" charset="-120"/>
               </a:rPr>
-              <a:t>核心概念 · 核心功能 · 應用情境</a:t>
+              <a:t>產品終局 · v0.4.2 → v0.5.0 · Phase 0–4</a:t>
             </a:r>
             <a:endParaRPr lang="en-US" sz="1300" dirty="0"/>
           </a:p>
@@ -10395,7 +10395,7 @@
                 <a:ea typeface="Microsoft JhengHei" pitchFamily="34" charset="-122"/>
                 <a:cs typeface="Microsoft JhengHei" pitchFamily="34" charset="-120"/>
               </a:rPr>
-              <a:t>OAuth 與同步在 Phase 2 的使用者環境執行,hosted 不持有 refresh token。</a:t>
+              <a:t>Phase 2 在使用者控制環境完成授權、同步、正規化與撤銷;hosted 不持有 provider token。</a:t>
             </a:r>
             <a:endParaRPr lang="en-US" sz="2000" dirty="0"/>
           </a:p>
@@ -10590,7 +10590,7 @@
                 <a:ea typeface="Arial" pitchFamily="34" charset="-122"/>
                 <a:cs typeface="Arial" pitchFamily="34" charset="-120"/>
               </a:rPr>
-              <a:t>Webhook</a:t>
+              <a:t>Revoke</a:t>
             </a:r>
             <a:endParaRPr lang="en-US" sz="1900" dirty="0"/>
           </a:p>
@@ -10915,7 +10915,7 @@
                 <a:ea typeface="Microsoft JhengHei" pitchFamily="34" charset="-122"/>
                 <a:cs typeface="Microsoft JhengHei" pitchFamily="34" charset="-120"/>
               </a:rPr>
-              <a:t>Fitbit</a:t>
+              <a:t>Oura</a:t>
             </a:r>
             <a:endParaRPr lang="en-US" sz="1300" dirty="0"/>
           </a:p>
@@ -10980,7 +10980,7 @@
                 <a:ea typeface="Microsoft JhengHei" pitchFamily="34" charset="-122"/>
                 <a:cs typeface="Microsoft JhengHei" pitchFamily="34" charset="-120"/>
               </a:rPr>
-              <a:t>TrainingPeaks</a:t>
+              <a:t>WHOOP</a:t>
             </a:r>
             <a:endParaRPr lang="en-US" sz="1300" dirty="0"/>
           </a:p>
@@ -11045,7 +11045,7 @@
                 <a:ea typeface="Microsoft JhengHei" pitchFamily="34" charset="-122"/>
                 <a:cs typeface="Microsoft JhengHei" pitchFamily="34" charset="-120"/>
               </a:rPr>
-              <a:t>Google Calendar</a:t>
+              <a:t>Manual / CSV</a:t>
             </a:r>
             <a:endParaRPr lang="en-US" sz="1300" dirty="0"/>
           </a:p>
@@ -11110,7 +11110,7 @@
                 <a:ea typeface="Microsoft JhengHei" pitchFamily="34" charset="-122"/>
                 <a:cs typeface="Microsoft JhengHei" pitchFamily="34" charset="-120"/>
               </a:rPr>
-              <a:t>Notion</a:t>
+              <a:t>Google Health</a:t>
             </a:r>
             <a:endParaRPr lang="en-US" sz="1300" dirty="0"/>
           </a:p>
@@ -11149,7 +11149,7 @@
                 <a:ea typeface="Microsoft JhengHei" pitchFamily="34" charset="-122"/>
                 <a:cs typeface="Microsoft JhengHei" pitchFamily="34" charset="-120"/>
               </a:rPr>
-              <a:t>新增一家資料源不用動上層;而在 Phase 1,這一層根本不在我們這邊。</a:t>
+              <a:t>目前 6 家 parser;Oura／WHOOP 尚待真實去識別化 fixture。新增來源不改 Decision Engine。</a:t>
             </a:r>
             <a:endParaRPr lang="en-US" sz="1400" dirty="0"/>
           </a:p>
@@ -11323,7 +11323,7 @@
                 <a:ea typeface="Microsoft JhengHei" pitchFamily="34" charset="-122"/>
                 <a:cs typeface="Microsoft JhengHei" pitchFamily="34" charset="-120"/>
               </a:rPr>
-              <a:t>對外開放的六個 tool</a:t>
+              <a:t>v0.5.0 規劃的十個 public tools</a:t>
             </a:r>
             <a:endParaRPr lang="en-US" sz="3400" dirty="0"/>
           </a:p>
@@ -11365,7 +11365,7 @@
                 <a:ea typeface="Microsoft JhengHei" pitchFamily="34" charset="-122"/>
                 <a:cs typeface="Microsoft JhengHei" pitchFamily="34" charset="-120"/>
               </a:rPr>
-              <a:t>這就是產品的能力清單 —— 任何支援 MCP 的客戶端都能直接呼叫。</a:t>
+              <a:t>v0.4.2 已公開 6 個;v0.5.0 整合完成後新增 workout 與 coverage／trace／outcome。</a:t>
             </a:r>
             <a:endParaRPr lang="en-US" sz="2000" dirty="0"/>
           </a:p>
@@ -11454,7 +11454,8 @@
                 <a:ea typeface="Arial" pitchFamily="34" charset="-122"/>
                 <a:cs typeface="Arial" pitchFamily="34" charset="-120"/>
               </a:rPr>
-              <a:t>assess_fitness_state</a:t>
+              <a:t>assess_fitness_state
+get_evidence_coverage</a:t>
             </a:r>
             <a:endParaRPr lang="en-US" sz="1350" dirty="0"/>
           </a:p>
@@ -11496,7 +11497,7 @@
                 <a:ea typeface="Arial" pitchFamily="34" charset="-122"/>
                 <a:cs typeface="Arial" pitchFamily="34" charset="-120"/>
               </a:rPr>
-              <a:t>從證據算出當前狀態</a:t>
+              <a:t>狀態與訊號覆蓋</a:t>
             </a:r>
             <a:endParaRPr lang="en-US" sz="950" dirty="0"/>
           </a:p>
@@ -11605,7 +11606,8 @@
                 <a:ea typeface="Arial" pitchFamily="34" charset="-122"/>
                 <a:cs typeface="Arial" pitchFamily="34" charset="-120"/>
               </a:rPr>
-              <a:t>decide_session</a:t>
+              <a:t>decide_session
+explain_decision</a:t>
             </a:r>
             <a:endParaRPr lang="en-US" sz="1350" dirty="0"/>
           </a:p>
@@ -11647,7 +11649,7 @@
                 <a:ea typeface="Arial" pitchFamily="34" charset="-122"/>
                 <a:cs typeface="Arial" pitchFamily="34" charset="-120"/>
               </a:rPr>
-              <a:t>今天的課表要不要改,改成什麼</a:t>
+              <a:t>決策與版本化 trace</a:t>
             </a:r>
             <a:endParaRPr lang="en-US" sz="950" dirty="0"/>
           </a:p>
@@ -11907,7 +11909,8 @@
                 <a:ea typeface="Arial" pitchFamily="34" charset="-122"/>
                 <a:cs typeface="Arial" pitchFamily="34" charset="-120"/>
               </a:rPr>
-              <a:t>generate_plan</a:t>
+              <a:t>generate_plan
+generate_workout</a:t>
             </a:r>
             <a:endParaRPr lang="en-US" sz="1350" dirty="0"/>
           </a:p>
@@ -11949,7 +11952,7 @@
                 <a:ea typeface="Arial" pitchFamily="34" charset="-122"/>
                 <a:cs typeface="Arial" pitchFamily="34" charset="-120"/>
               </a:rPr>
-              <a:t>產生多週期計畫</a:t>
+              <a:t>多週計畫與單次 workout</a:t>
             </a:r>
             <a:endParaRPr lang="en-US" sz="950" dirty="0"/>
           </a:p>
@@ -12209,7 +12212,8 @@
                 <a:ea typeface="Arial" pitchFamily="34" charset="-122"/>
                 <a:cs typeface="Arial" pitchFamily="34" charset="-120"/>
               </a:rPr>
-              <a:t>commit_adjust_plan</a:t>
+              <a:t>commit_adjust_plan
+submit_outcome</a:t>
             </a:r>
             <a:endParaRPr lang="en-US" sz="1350" dirty="0"/>
           </a:p>
@@ -12251,7 +12255,7 @@
                 <a:ea typeface="Arial" pitchFamily="34" charset="-122"/>
                 <a:cs typeface="Arial" pitchFamily="34" charset="-120"/>
               </a:rPr>
-              <a:t>兩階段提交,寫回計畫</a:t>
+              <a:t>提交計畫與結果回報</a:t>
             </a:r>
             <a:endParaRPr lang="en-US" sz="950" dirty="0"/>
           </a:p>
@@ -12487,7 +12491,7 @@
                 <a:ea typeface="Microsoft JhengHei" pitchFamily="34" charset="-122"/>
                 <a:cs typeface="Microsoft JhengHei" pitchFamily="34" charset="-120"/>
               </a:rPr>
-              <a:t>先講清楚我們在蓋什麼,再講它能做什麼,最後用真實情境驗收。</a:t>
+              <a:t>先看產品終局,再看已交付能力,最後用真實情境與 roadmap 驗收。</a:t>
             </a:r>
             <a:endParaRPr lang="en-US" sz="2000" dirty="0"/>
           </a:p>
@@ -12779,7 +12783,7 @@
                 <a:ea typeface="Microsoft JhengHei" pitchFamily="34" charset="-122"/>
                 <a:cs typeface="Microsoft JhengHei" pitchFamily="34" charset="-120"/>
               </a:rPr>
-              <a:t>六個 tool,以及背後那個不呼叫模型的決策引擎</a:t>
+              <a:t>目前 6 tools、下一版 10 tools,以及版本化的 Engine 與 Rule Packages</a:t>
             </a:r>
             <a:endParaRPr lang="en-US" sz="1250" dirty="0"/>
           </a:p>
@@ -12925,7 +12929,7 @@
                 <a:ea typeface="Microsoft JhengHei" pitchFamily="34" charset="-122"/>
                 <a:cs typeface="Microsoft JhengHei" pitchFamily="34" charset="-120"/>
               </a:rPr>
-              <a:t>六個使用者真的會問的問題,以及每一題打到哪幾層</a:t>
+              <a:t>六個真實問題,以及從 v0.5.0 到 private engine 的交付順序</a:t>
             </a:r>
             <a:endParaRPr lang="en-US" sz="1250" dirty="0"/>
           </a:p>
@@ -13748,7 +13752,7 @@
                 <a:ea typeface="Microsoft JhengHei" pitchFamily="34" charset="-122"/>
                 <a:cs typeface="Microsoft JhengHei" pitchFamily="34" charset="-120"/>
               </a:rPr>
-              <a:t>三種部署,一條資料界線</a:t>
+              <a:t>三種部署,三句不同的隱私承諾</a:t>
             </a:r>
             <a:endParaRPr lang="en-US" sz="3400" dirty="0"/>
           </a:p>
@@ -13790,7 +13794,7 @@
                 <a:ea typeface="Microsoft JhengHei" pitchFamily="34" charset="-122"/>
                 <a:cs typeface="Microsoft JhengHei" pitchFamily="34" charset="-120"/>
               </a:rPr>
-              <a:t>同一套 domain package,差別只在 Evidence 在哪裡被處理。</a:t>
+              <a:t>同一顆 Engine 與 Rule Packages;差別是 Evidence、token、state 與計算由誰控制。</a:t>
             </a:r>
             <a:endParaRPr lang="en-US" sz="2000" dirty="0"/>
           </a:p>
@@ -13879,7 +13883,7 @@
                 <a:ea typeface="Arial" pitchFamily="34" charset="-122"/>
                 <a:cs typeface="Arial" pitchFamily="34" charset="-120"/>
               </a:rPr>
-              <a:t>Hosted remote</a:t>
+              <a:t>Local desktop</a:t>
             </a:r>
             <a:endParaRPr lang="en-US" sz="1600" dirty="0"/>
           </a:p>
@@ -13918,7 +13922,7 @@
                 <a:ea typeface="Microsoft JhengHei" pitchFamily="34" charset="-122"/>
                 <a:cs typeface="Microsoft JhengHei" pitchFamily="34" charset="-120"/>
               </a:rPr>
-              <a:t>短暫處理最小化 Evidence,永遠無狀態</a:t>
+              <a:t>今天可用:本機 MCPB 與手動／匯出 Evidence</a:t>
             </a:r>
             <a:endParaRPr lang="en-US" sz="1300" dirty="0"/>
           </a:p>
@@ -14007,7 +14011,7 @@
                 <a:ea typeface="Arial" pitchFamily="34" charset="-122"/>
                 <a:cs typeface="Arial" pitchFamily="34" charset="-120"/>
               </a:rPr>
-              <a:t>Hosted 的界線</a:t>
+              <a:t>User-controlled private</a:t>
             </a:r>
             <a:endParaRPr lang="en-US" sz="1600" dirty="0"/>
           </a:p>
@@ -14046,7 +14050,7 @@
                 <a:ea typeface="Microsoft JhengHei" pitchFamily="34" charset="-122"/>
                 <a:cs typeface="Microsoft JhengHei" pitchFamily="34" charset="-120"/>
               </a:rPr>
-              <a:t>不直連供應商、不持有 refresh token</a:t>
+              <a:t>Phase 2:connectors、state、plan、decision 都在你的環境</a:t>
             </a:r>
             <a:endParaRPr lang="en-US" sz="1300" dirty="0"/>
           </a:p>
@@ -14135,7 +14139,7 @@
                 <a:ea typeface="Arial" pitchFamily="34" charset="-122"/>
                 <a:cs typeface="Arial" pitchFamily="34" charset="-120"/>
               </a:rPr>
-              <a:t>Local / private</a:t>
+              <a:t>Controlled mobile</a:t>
             </a:r>
             <a:endParaRPr lang="en-US" sz="1600" dirty="0"/>
           </a:p>
@@ -14174,7 +14178,7 @@
                 <a:ea typeface="Microsoft JhengHei" pitchFamily="34" charset="-122"/>
                 <a:cs typeface="Microsoft JhengHei" pitchFamily="34" charset="-120"/>
               </a:rPr>
-              <a:t>connectors 與計算都在你的機器上跑</a:t>
+              <a:t>Phase 3:pairing／tunnel 先連回 private engine</a:t>
             </a:r>
             <a:endParaRPr lang="en-US" sz="1300" dirty="0"/>
           </a:p>
@@ -14263,7 +14267,7 @@
                 <a:ea typeface="Arial" pitchFamily="34" charset="-122"/>
                 <a:cs typeface="Arial" pitchFamily="34" charset="-120"/>
               </a:rPr>
-              <a:t>Private data plane</a:t>
+              <a:t>Hosted remote</a:t>
             </a:r>
             <a:endParaRPr lang="en-US" sz="1600" dirty="0"/>
           </a:p>
@@ -14302,7 +14306,7 @@
                 <a:ea typeface="Microsoft JhengHei" pitchFamily="34" charset="-122"/>
                 <a:cs typeface="Microsoft JhengHei" pitchFamily="34" charset="-120"/>
               </a:rPr>
-              <a:t>只有 user-controlled private 能做到原始資料不離開控制邊界</a:t>
+              <a:t>只承諾最小化、transient、不留存;目前 Blocked</a:t>
             </a:r>
             <a:endParaRPr lang="en-US" sz="1300" dirty="0"/>
           </a:p>
@@ -20641,7 +20645,7 @@
                 <a:ea typeface="Microsoft JhengHei" pitchFamily="34" charset="-122"/>
                 <a:cs typeface="Microsoft JhengHei" pitchFamily="34" charset="-120"/>
               </a:rPr>
-              <a:t>現況與待做,一張表講完</a:t>
+              <a:t>從已發行版本倒推下一階段</a:t>
             </a:r>
             <a:endParaRPr lang="en-US" sz="3400" dirty="0"/>
           </a:p>
@@ -20683,7 +20687,7 @@
                 <a:ea typeface="Microsoft JhengHei" pitchFamily="34" charset="-122"/>
                 <a:cs typeface="Microsoft JhengHei" pitchFamily="34" charset="-120"/>
               </a:rPr>
-              <a:t>已完成的附查證數字;待做的不寫沒有出處的驗收門檻。</a:t>
+              <a:t>先關閉 v0.5.0,再用產品頁驗證市場,之後進入 private engine、mobile 與 team。</a:t>
             </a:r>
             <a:endParaRPr lang="en-US" sz="2000" dirty="0"/>
           </a:p>
@@ -20811,7 +20815,7 @@
                 <a:ea typeface="Microsoft JhengHei" pitchFamily="34" charset="-122"/>
                 <a:cs typeface="Microsoft JhengHei" pitchFamily="34" charset="-120"/>
               </a:rPr>
-              <a:t>資料標準化</a:t>
+              <a:t>已發行 v0.4.2</a:t>
             </a:r>
             <a:endParaRPr lang="en-US" sz="1300" dirty="0"/>
           </a:p>
@@ -20850,7 +20854,7 @@
                 <a:ea typeface="Microsoft JhengHei" pitchFamily="34" charset="-122"/>
                 <a:cs typeface="Microsoft JhengHei" pitchFamily="34" charset="-120"/>
               </a:rPr>
-              <a:t>Apple Health／Garmin／Google／Strava／Oura／WHOOP／Oura／WHOOP</a:t>
+              <a:t>Desktop MCPB · 6 public tools</a:t>
             </a:r>
             <a:endParaRPr lang="en-US" sz="1050" dirty="0"/>
           </a:p>
@@ -20916,7 +20920,7 @@
                 <a:ea typeface="Microsoft JhengHei" pitchFamily="34" charset="-122"/>
                 <a:cs typeface="Microsoft JhengHei" pitchFamily="34" charset="-120"/>
               </a:rPr>
-              <a:t>現況  6 家 parser,registry 6 家（8 種方言）</a:t>
+              <a:t>Engine 1.6.0 · legacy Library 1.4.0</a:t>
             </a:r>
             <a:endParaRPr lang="en-US" sz="1000" dirty="0"/>
           </a:p>
@@ -21044,7 +21048,7 @@
                 <a:ea typeface="Microsoft JhengHei" pitchFamily="34" charset="-122"/>
                 <a:cs typeface="Microsoft JhengHei" pitchFamily="34" charset="-120"/>
               </a:rPr>
-              <a:t>確定性計算</a:t>
+              <a:t>main 已完成</a:t>
             </a:r>
             <a:endParaRPr lang="en-US" sz="1300" dirty="0"/>
           </a:p>
@@ -21083,7 +21087,7 @@
                 <a:ea typeface="Microsoft JhengHei" pitchFamily="34" charset="-122"/>
                 <a:cs typeface="Microsoft JhengHei" pitchFamily="34" charset="-120"/>
               </a:rPr>
-              <a:t>ACWR／ATL／CTL／TSB 與分肌群疲勞</a:t>
+              <a:t>trace／outcome／continuity／package lifecycle</a:t>
             </a:r>
             <a:endParaRPr lang="en-US" sz="1050" dirty="0"/>
           </a:p>
@@ -21149,7 +21153,7 @@
                 <a:ea typeface="Microsoft JhengHei" pitchFamily="34" charset="-122"/>
                 <a:cs typeface="Microsoft JhengHei" pitchFamily="34" charset="-120"/>
               </a:rPr>
-              <a:t>現況  470 tests、20 golden cases 全綠</a:t>
+              <a:t>graph viewer · harness · regression gate</a:t>
             </a:r>
             <a:endParaRPr lang="en-US" sz="1000" dirty="0"/>
           </a:p>
@@ -21277,7 +21281,7 @@
                 <a:ea typeface="Microsoft JhengHei" pitchFamily="34" charset="-122"/>
                 <a:cs typeface="Microsoft JhengHei" pitchFamily="34" charset="-120"/>
               </a:rPr>
-              <a:t>六個對外 tool</a:t>
+              <a:t>下一版 v0.5.0</a:t>
             </a:r>
             <a:endParaRPr lang="en-US" sz="1300" dirty="0"/>
           </a:p>
@@ -21316,7 +21320,7 @@
                 <a:ea typeface="Microsoft JhengHei" pitchFamily="34" charset="-122"/>
                 <a:cs typeface="Microsoft JhengHei" pitchFamily="34" charset="-120"/>
               </a:rPr>
-              <a:t>assess／decide／plan 三類</a:t>
+              <a:t>10 tools · Engine 1.6.0</a:t>
             </a:r>
             <a:endParaRPr lang="en-US" sz="1050" dirty="0"/>
           </a:p>
@@ -21382,7 +21386,7 @@
                 <a:ea typeface="Microsoft JhengHei" pitchFamily="34" charset="-122"/>
                 <a:cs typeface="Microsoft JhengHei" pitchFamily="34" charset="-120"/>
               </a:rPr>
-              <a:t>現況  單次決策 0.443 ms</a:t>
+              <a:t>base_rules 1.1.0 · planned</a:t>
             </a:r>
             <a:endParaRPr lang="en-US" sz="1000" dirty="0"/>
           </a:p>
@@ -21510,7 +21514,7 @@
                 <a:ea typeface="Microsoft JhengHei" pitchFamily="34" charset="-122"/>
                 <a:cs typeface="Microsoft JhengHei" pitchFamily="34" charset="-120"/>
               </a:rPr>
-              <a:t>Transport</a:t>
+              <a:t>Phase 0</a:t>
             </a:r>
             <a:endParaRPr lang="en-US" sz="1300" dirty="0"/>
           </a:p>
@@ -21549,7 +21553,7 @@
                 <a:ea typeface="Microsoft JhengHei" pitchFamily="34" charset="-122"/>
                 <a:cs typeface="Microsoft JhengHei" pitchFamily="34" charset="-120"/>
               </a:rPr>
-              <a:t>stdio 與 Streamable HTTP</a:t>
+              <a:t>整合 workout／防注入與 privacy</a:t>
             </a:r>
             <a:endParaRPr lang="en-US" sz="1050" dirty="0"/>
           </a:p>
@@ -21615,7 +21619,7 @@
                 <a:ea typeface="Microsoft JhengHei" pitchFamily="34" charset="-122"/>
                 <a:cs typeface="Microsoft JhengHei" pitchFamily="34" charset="-120"/>
               </a:rPr>
-              <a:t>現況  兩種都通</a:t>
+              <a:t>pack · gates · publish</a:t>
             </a:r>
             <a:endParaRPr lang="en-US" sz="1000" dirty="0"/>
           </a:p>
@@ -21743,7 +21747,7 @@
                 <a:ea typeface="Microsoft JhengHei" pitchFamily="34" charset="-122"/>
                 <a:cs typeface="Microsoft JhengHei" pitchFamily="34" charset="-120"/>
               </a:rPr>
-              <a:t>OAuth Resource Server</a:t>
+              <a:t>Phase 1</a:t>
             </a:r>
             <a:endParaRPr lang="en-US" sz="1300" dirty="0"/>
           </a:p>
@@ -21782,7 +21786,7 @@
                 <a:ea typeface="Microsoft JhengHei" pitchFamily="34" charset="-122"/>
                 <a:cs typeface="Microsoft JhengHei" pitchFamily="34" charset="-120"/>
               </a:rPr>
-              <a:t>簽章驗證、issuer、audience、scope</a:t>
+              <a:t>pacevera.com 產品頁與真實 demo</a:t>
             </a:r>
             <a:endParaRPr lang="en-US" sz="1050" dirty="0"/>
           </a:p>
@@ -21848,7 +21852,7 @@
                 <a:ea typeface="Microsoft JhengHei" pitchFamily="34" charset="-122"/>
                 <a:cs typeface="Microsoft JhengHei" pitchFamily="34" charset="-120"/>
               </a:rPr>
-              <a:t>現況  private-development adapter；待做 production authorization server</a:t>
+              <a:t>3–5 interviews · activation／retention</a:t>
             </a:r>
             <a:endParaRPr lang="en-US" sz="1000" dirty="0"/>
           </a:p>
@@ -21976,7 +21980,7 @@
                 <a:ea typeface="Microsoft JhengHei" pitchFamily="34" charset="-122"/>
                 <a:cs typeface="Microsoft JhengHei" pitchFamily="34" charset="-120"/>
               </a:rPr>
-              <a:t>遠端部署</a:t>
+              <a:t>Phase 2</a:t>
             </a:r>
             <a:endParaRPr lang="en-US" sz="1300" dirty="0"/>
           </a:p>
@@ -22015,7 +22019,7 @@
                 <a:ea typeface="Microsoft JhengHei" pitchFamily="34" charset="-122"/>
                 <a:cs typeface="Microsoft JhengHei" pitchFamily="34" charset="-120"/>
               </a:rPr>
-              <a:t>HTTPS /mcp —— 手機場景的前提</a:t>
+              <a:t>Local private engine MVP</a:t>
             </a:r>
             <a:endParaRPr lang="en-US" sz="1050" dirty="0"/>
           </a:p>
@@ -22081,7 +22085,7 @@
                 <a:ea typeface="Microsoft JhengHei" pitchFamily="34" charset="-122"/>
                 <a:cs typeface="Microsoft JhengHei" pitchFamily="34" charset="-120"/>
               </a:rPr>
-              <a:t>待做  桌機上架不需要它</a:t>
+              <a:t>repository · connectors · continuity</a:t>
             </a:r>
             <a:endParaRPr lang="en-US" sz="1000" dirty="0"/>
           </a:p>
@@ -22209,7 +22213,7 @@
                 <a:ea typeface="Microsoft JhengHei" pitchFamily="34" charset="-122"/>
                 <a:cs typeface="Microsoft JhengHei" pitchFamily="34" charset="-120"/>
               </a:rPr>
-              <a:t>User-controlled private engine</a:t>
+              <a:t>Phase 3</a:t>
             </a:r>
             <a:endParaRPr lang="en-US" sz="1300" dirty="0"/>
           </a:p>
@@ -22248,7 +22252,7 @@
                 <a:ea typeface="Microsoft JhengHei" pitchFamily="34" charset="-122"/>
                 <a:cs typeface="Microsoft JhengHei" pitchFamily="34" charset="-120"/>
               </a:rPr>
-              <a:t>connectors 與計算搬進使用者環境</a:t>
+              <a:t>Controlled mobile · cross-host</a:t>
             </a:r>
             <a:endParaRPr lang="en-US" sz="1050" dirty="0"/>
           </a:p>
@@ -22314,7 +22318,7 @@
                 <a:ea typeface="Microsoft JhengHei" pitchFamily="34" charset="-122"/>
                 <a:cs typeface="Microsoft JhengHei" pitchFamily="34" charset="-120"/>
               </a:rPr>
-              <a:t>待做  local bundle／持久層／connector 權限</a:t>
+              <a:t>hosted remote 維持 Blocked</a:t>
             </a:r>
             <a:endParaRPr lang="en-US" sz="1000" dirty="0"/>
           </a:p>
@@ -22442,7 +22446,7 @@
                 <a:ea typeface="Microsoft JhengHei" pitchFamily="34" charset="-122"/>
                 <a:cs typeface="Microsoft JhengHei" pitchFamily="34" charset="-120"/>
               </a:rPr>
-              <a:t>計畫的持久層</a:t>
+              <a:t>Phase 4</a:t>
             </a:r>
             <a:endParaRPr lang="en-US" sz="1300" dirty="0"/>
           </a:p>
@@ -22481,7 +22485,7 @@
                 <a:ea typeface="Microsoft JhengHei" pitchFamily="34" charset="-122"/>
                 <a:cs typeface="Microsoft JhengHei" pitchFamily="34" charset="-120"/>
               </a:rPr>
-              <a:t>plan 與 planned workout 的表</a:t>
+              <a:t>Team／Enterprise · REST／SDK</a:t>
             </a:r>
             <a:endParaRPr lang="en-US" sz="1050" dirty="0"/>
           </a:p>
@@ -22547,7 +22551,7 @@
                 <a:ea typeface="Microsoft JhengHei" pitchFamily="34" charset="-122"/>
                 <a:cs typeface="Microsoft JhengHei" pitchFamily="34" charset="-120"/>
               </a:rPr>
-              <a:t>待做  列在 Future Migrations</a:t>
+              <a:t>governance · private deployment · pilot</a:t>
             </a:r>
             <a:endParaRPr lang="en-US" sz="1000" dirty="0"/>
           </a:p>
@@ -22675,7 +22679,7 @@
                 <a:ea typeface="Microsoft JhengHei" pitchFamily="34" charset="-122"/>
                 <a:cs typeface="Microsoft JhengHei" pitchFamily="34" charset="-120"/>
               </a:rPr>
-              <a:t>協定升級</a:t>
+              <a:t>Remote GO gate</a:t>
             </a:r>
             <a:endParaRPr lang="en-US" sz="1300" dirty="0"/>
           </a:p>
@@ -22714,7 +22718,7 @@
                 <a:ea typeface="Microsoft JhengHei" pitchFamily="34" charset="-122"/>
                 <a:cs typeface="Microsoft JhengHei" pitchFamily="34" charset="-120"/>
               </a:rPr>
-              <a:t>2025-06-18 → 2026-07-28</a:t>
+              <a:t>auth · HTTPS · redaction · privacy · E2E</a:t>
             </a:r>
             <a:endParaRPr lang="en-US" sz="1050" dirty="0"/>
           </a:p>
@@ -22780,7 +22784,7 @@
                 <a:ea typeface="Microsoft JhengHei" pitchFamily="34" charset="-122"/>
                 <a:cs typeface="Microsoft JhengHei" pitchFamily="34" charset="-120"/>
               </a:rPr>
-              <a:t>待做  走 dual-era,不直接切</a:t>
+              <a:t>全部成立且有付費需求才 GO</a:t>
             </a:r>
             <a:endParaRPr lang="en-US" sz="1000" dirty="0"/>
           </a:p>
@@ -23599,7 +23603,7 @@
                 <a:ea typeface="Microsoft JhengHei" pitchFamily="34" charset="-122"/>
                 <a:cs typeface="Microsoft JhengHei" pitchFamily="34" charset="-120"/>
               </a:rPr>
-              <a:t>是那個可重現的判斷,</a:t>
+              <a:t>是連續 Evidence → 可追溯 Decision,</a:t>
             </a:r>
             <a:endParaRPr lang="en-US" sz="3300" dirty="0"/>
           </a:p>
@@ -23619,7 +23623,7 @@
                 <a:ea typeface="Microsoft JhengHei" pitchFamily="34" charset="-122"/>
                 <a:cs typeface="Microsoft JhengHei" pitchFamily="34" charset="-120"/>
               </a:rPr>
-              <a:t>不是被保存下來的資料。</a:t>
+              <a:t>而資料始終由使用者控制。</a:t>
             </a:r>
             <a:endParaRPr lang="en-US" sz="3300" dirty="0"/>
           </a:p>
@@ -23724,7 +23728,7 @@
                 <a:ea typeface="Microsoft JhengHei" pitchFamily="34" charset="-122"/>
                 <a:cs typeface="Microsoft JhengHei" pitchFamily="34" charset="-120"/>
               </a:rPr>
-              <a:t>下一步:先完成 P0 隱私契約與 P1 local private engine;remote 是後續 access channel,企業私有部署再後續</a:t>
+              <a:t>下一步:先發布 v0.5.0 → pacevera.com 驗證 → local private engine;remote 仍是後續 access channel</a:t>
             </a:r>
             <a:endParaRPr lang="en-US" sz="1250" dirty="0"/>
           </a:p>
@@ -24944,7 +24948,7 @@
                 <a:ea typeface="Microsoft JhengHei" pitchFamily="34" charset="-122"/>
                 <a:cs typeface="Microsoft JhengHei" pitchFamily="34" charset="-120"/>
               </a:rPr>
-              <a:t>使用者要教練能力,不要交出原始資料</a:t>
+              <a:t>使用者要連續的決策能力,不要再交出健康歷史</a:t>
             </a:r>
             <a:endParaRPr lang="en-US" sz="3400" dirty="0"/>
           </a:p>
@@ -24986,7 +24990,7 @@
                 <a:ea typeface="Microsoft JhengHei" pitchFamily="34" charset="-122"/>
                 <a:cs typeface="Microsoft JhengHei" pitchFamily="34" charset="-120"/>
               </a:rPr>
-              <a:t>host 當大腦與對話介面,Fitness MCP 當背後的運動科學計算與安全判斷引擎。</a:t>
+              <a:t>AI host 負責理解與表達;Pacevera 在使用者控制的資料邊界內負責計算、仲裁與追溯。</a:t>
             </a:r>
             <a:endParaRPr lang="en-US" sz="2000" dirty="0"/>
           </a:p>
@@ -25093,7 +25097,7 @@
                 <a:ea typeface="Microsoft JhengHei" pitchFamily="34" charset="-122"/>
                 <a:cs typeface="Microsoft JhengHei" pitchFamily="34" charset="-120"/>
               </a:rPr>
-              <a:t>AI 的教練能力:今天能不能練、該練哪裡、為什麼</a:t>
+              <a:t>今天照不照原課表、具體改成什麼、為什麼、缺什麼</a:t>
             </a:r>
             <a:endParaRPr lang="en-US" sz="1700" dirty="0"/>
           </a:p>
@@ -25200,7 +25204,7 @@
                 <a:ea typeface="Microsoft JhengHei" pitchFamily="34" charset="-122"/>
                 <a:cs typeface="Microsoft JhengHei" pitchFamily="34" charset="-120"/>
               </a:rPr>
-              <a:t>Claude 和我們的 hosted MCP 看見完整的原始健康資料</a:t>
+              <a:t>每個 AI host 或 Pacevera hosted service 各自保存完整健康歷史</a:t>
             </a:r>
             <a:endParaRPr lang="en-US" sz="1700" dirty="0"/>
           </a:p>
@@ -25239,7 +25243,7 @@
                 <a:ea typeface="Microsoft JhengHei" pitchFamily="34" charset="-122"/>
                 <a:cs typeface="Microsoft JhengHei" pitchFamily="34" charset="-120"/>
               </a:rPr>
-              <a:t>收最小化證據、算完不留 —— 這是產品的前提,不是附加的隱私功能。</a:t>
+              <a:t>Local／private 保存 state;hosted 只做最小化 transient processing。兩者不能共用同一句隱私承諾。</a:t>
             </a:r>
             <a:endParaRPr lang="en-US" sz="1800" dirty="0"/>
           </a:p>
@@ -25413,7 +25417,7 @@
                 <a:ea typeface="Microsoft JhengHei" pitchFamily="34" charset="-122"/>
                 <a:cs typeface="Microsoft JhengHei" pitchFamily="34" charset="-120"/>
               </a:rPr>
-              <a:t>關鍵設計:我們什麼都不留</a:t>
+              <a:t>關鍵設計:資料由使用者控制</a:t>
             </a:r>
             <a:endParaRPr lang="en-US" sz="3400" dirty="0"/>
           </a:p>
@@ -25455,7 +25459,7 @@
                 <a:ea typeface="Microsoft JhengHei" pitchFamily="34" charset="-122"/>
                 <a:cs typeface="Microsoft JhengHei" pitchFamily="34" charset="-120"/>
               </a:rPr>
-              <a:t>最小化 Evidence 進來,算出決策就丟掉 —— hosted 這端不寫任何一張表。</a:t>
+              <a:t>Local／private 可保存可重算的 state、plan 與 decision history;hosted 不保存 raw Evidence。</a:t>
             </a:r>
             <a:endParaRPr lang="en-US" sz="2000" dirty="0"/>
           </a:p>
@@ -25520,7 +25524,7 @@
                 <a:ea typeface="Microsoft JhengHei" pitchFamily="34" charset="-122"/>
                 <a:cs typeface="Microsoft JhengHei" pitchFamily="34" charset="-120"/>
               </a:rPr>
-              <a:t>呼叫端送進來的</a:t>
+              <a:t>使用者控制環境保存</a:t>
             </a:r>
             <a:endParaRPr lang="en-US" sz="1300" dirty="0"/>
           </a:p>
@@ -25559,7 +25563,7 @@
                 <a:ea typeface="Microsoft JhengHei" pitchFamily="34" charset="-122"/>
                 <a:cs typeface="Microsoft JhengHei" pitchFamily="34" charset="-120"/>
               </a:rPr>
-              <a:t>HRV 42ms · 睡眠 5h20m · 昨日 TSS 148</a:t>
+              <a:t>Raw Evidence · provider token · longitudinal state · plan</a:t>
             </a:r>
             <a:endParaRPr lang="en-US" sz="1800" dirty="0"/>
           </a:p>
@@ -25624,7 +25628,7 @@
                 <a:ea typeface="Microsoft JhengHei" pitchFamily="34" charset="-122"/>
                 <a:cs typeface="Microsoft JhengHei" pitchFamily="34" charset="-120"/>
               </a:rPr>
-              <a:t>我們算完回傳的</a:t>
+              <a:t>AI host 最小化取得</a:t>
             </a:r>
             <a:endParaRPr lang="en-US" sz="1300" dirty="0"/>
           </a:p>
@@ -25663,7 +25667,7 @@
                 <a:ea typeface="Microsoft JhengHei" pitchFamily="34" charset="-122"/>
                 <a:cs typeface="Microsoft JhengHei" pitchFamily="34" charset="-120"/>
               </a:rPr>
-              <a:t>Intervals → Zone 2 · ACWR 1.52 · 急性負荷偏快</a:t>
+              <a:t>Decision from → to · reason · missing signals · versioned trace</a:t>
             </a:r>
             <a:endParaRPr lang="en-US" sz="1800" dirty="0"/>
           </a:p>
@@ -26438,7 +26442,7 @@
                 <a:ea typeface="Microsoft JhengHei" pitchFamily="34" charset="-122"/>
                 <a:cs typeface="Microsoft JhengHei" pitchFamily="34" charset="-120"/>
               </a:rPr>
-              <a:t>四層架構:原始資料停在界線之外</a:t>
+              <a:t>四層架構:資料邊界與決策責任分開</a:t>
             </a:r>
             <a:endParaRPr lang="en-US" sz="3400" dirty="0"/>
           </a:p>
@@ -26480,7 +26484,7 @@
                 <a:ea typeface="Microsoft JhengHei" pitchFamily="34" charset="-122"/>
                 <a:cs typeface="Microsoft JhengHei" pitchFamily="34" charset="-120"/>
               </a:rPr>
-              <a:t>每一層只做一件事;最下面那一層,hosted MCP 不直接連。</a:t>
+              <a:t>AI 可替換、Decision Engine 可重現、Evidence 與 token 留在 user-controlled boundary。</a:t>
             </a:r>
             <a:endParaRPr lang="en-US" sz="2000" dirty="0"/>
           </a:p>
@@ -26569,7 +26573,7 @@
                 <a:ea typeface="Arial" pitchFamily="34" charset="-122"/>
                 <a:cs typeface="Arial" pitchFamily="34" charset="-120"/>
               </a:rPr>
-              <a:t>Client Layer</a:t>
+              <a:t>AI / Client Layer</a:t>
             </a:r>
             <a:endParaRPr lang="en-US" sz="1500" dirty="0"/>
           </a:p>
@@ -26608,7 +26612,7 @@
                 <a:ea typeface="Microsoft JhengHei" pitchFamily="34" charset="-122"/>
                 <a:cs typeface="Microsoft JhengHei" pitchFamily="34" charset="-120"/>
               </a:rPr>
-              <a:t>ChatGPT · Claude · Gemini · Cursor · Web · Mobile App · Apple Watch · Voice</a:t>
+              <a:t>Claude · ChatGPT · Gemini · Web · Mobile · Team systems</a:t>
             </a:r>
             <a:endParaRPr lang="en-US" sz="1250" dirty="0"/>
           </a:p>
@@ -26697,7 +26701,7 @@
                 <a:ea typeface="Arial" pitchFamily="34" charset="-122"/>
                 <a:cs typeface="Arial" pitchFamily="34" charset="-120"/>
               </a:rPr>
-              <a:t>MCP Layer</a:t>
+              <a:t>Pacevera Interface</a:t>
             </a:r>
             <a:endParaRPr lang="en-US" sz="1500" dirty="0"/>
           </a:p>
@@ -26736,7 +26740,7 @@
                 <a:ea typeface="Microsoft JhengHei" pitchFamily="34" charset="-122"/>
                 <a:cs typeface="Microsoft JhengHei" pitchFamily="34" charset="-120"/>
               </a:rPr>
-              <a:t>Fitness MCP —— 六個 tool,確定性計算,無狀態</a:t>
+              <a:t>Desktop MCPB · private MCP · hosted remote · future REST / SDK</a:t>
             </a:r>
             <a:endParaRPr lang="en-US" sz="1250" dirty="0"/>
           </a:p>
@@ -26825,7 +26829,7 @@
                 <a:ea typeface="Arial" pitchFamily="34" charset="-122"/>
                 <a:cs typeface="Arial" pitchFamily="34" charset="-120"/>
               </a:rPr>
-              <a:t>Service Layer</a:t>
+              <a:t>Decision Infrastructure</a:t>
             </a:r>
             <a:endParaRPr lang="en-US" sz="1500" dirty="0"/>
           </a:p>
@@ -26864,7 +26868,7 @@
                 <a:ea typeface="Microsoft JhengHei" pitchFamily="34" charset="-122"/>
                 <a:cs typeface="Microsoft JhengHei" pitchFamily="34" charset="-120"/>
               </a:rPr>
-              <a:t>Semantic Engine · Training Load · Decision Engine · Planning · Knowledge Graph</a:t>
+              <a:t>Semantic State · Decision Engine · Rule Packages · Decision Graph</a:t>
             </a:r>
             <a:endParaRPr lang="en-US" sz="1250" dirty="0"/>
           </a:p>
@@ -26953,7 +26957,7 @@
                 <a:ea typeface="Arial" pitchFamily="34" charset="-122"/>
                 <a:cs typeface="Arial" pitchFamily="34" charset="-120"/>
               </a:rPr>
-              <a:t>Evidence 來源</a:t>
+              <a:t>User-controlled Evidence</a:t>
             </a:r>
             <a:endParaRPr lang="en-US" sz="1500" dirty="0"/>
           </a:p>
@@ -26992,7 +26996,7 @@
                 <a:ea typeface="Microsoft JhengHei" pitchFamily="34" charset="-122"/>
                 <a:cs typeface="Microsoft JhengHei" pitchFamily="34" charset="-120"/>
               </a:rPr>
-              <a:t>Apple Health · Garmin · Strava —— 由 host 或使用者的 gateway 解析,不經過我們</a:t>
+              <a:t>Local connectors · provider tokens · raw history · plans · outcomes</a:t>
             </a:r>
             <a:endParaRPr lang="en-US" sz="1250" dirty="0"/>
           </a:p>

</xml_diff>